<commit_message>
build(pdf): regenerar bundles consolidados y PDF general del curso
Regenera docs/pdfs/curso-completo.pdf, docs/presentaciones/curso-completo.pptx
y los 8 bundles por parte tras resolver los 112 notebooks. El bundle movil
(classes.js) no cambia: embebe campos del README (sin cambios), y los notebooks
van enlazados a Colab/GitHub (ya reales en main).

Co-Authored-By: Claude Opus 4.8 <noreply@anthropic.com>
</commit_message>
<xml_diff>
--- a/docs/presentaciones/parts/parte-3-estadistica-inferencial-completa.pptx
+++ b/docs/presentaciones/parts/parte-3-estadistica-inferencial-completa.pptx
@@ -4582,7 +4582,7 @@
                 </a:solidFill>
                 <a:latin typeface="Segoe UI"/>
               </a:rPr>
-              <a:t>Primer bloque ejecutable del notebook.</a:t>
+              <a:t>H₀: μ = 20 vs H₁: μ ≠ 20. El IC95 % y el p-value son la misma información: si el IC excluye 20, se rechaza H₀.</a:t>
             </a:r>
           </a:p>
         </p:txBody>
@@ -4669,7 +4669,254 @@
                 </a:solidFill>
                 <a:latin typeface="Courier New"/>
               </a:rPr>
-              <a:t># Imports y configuración inicial</a:t>
+              <a:t>import numpy as np</a:t>
+            </a:r>
+          </a:p>
+          <a:p>
+            <a:pPr>
+              <a:defRPr sz="1200" b="0">
+                <a:solidFill>
+                  <a:srgbClr val="F8FAFC"/>
+                </a:solidFill>
+                <a:latin typeface="Courier New"/>
+              </a:defRPr>
+            </a:pPr>
+            <a:r>
+              <a:rPr sz="1200" b="0">
+                <a:solidFill>
+                  <a:srgbClr val="F8FAFC"/>
+                </a:solidFill>
+                <a:latin typeface="Courier New"/>
+              </a:rPr>
+              <a:t>from scipy import stats</a:t>
+            </a:r>
+          </a:p>
+          <a:p>
+            <a:pPr>
+              <a:defRPr sz="1200" b="0">
+                <a:solidFill>
+                  <a:srgbClr val="F8FAFC"/>
+                </a:solidFill>
+                <a:latin typeface="Courier New"/>
+              </a:defRPr>
+            </a:pPr>
+            <a:r>
+              <a:rPr sz="1200" b="0">
+                <a:solidFill>
+                  <a:srgbClr val="F8FAFC"/>
+                </a:solidFill>
+                <a:latin typeface="Courier New"/>
+              </a:rPr>
+              <a:t>import matplotlib.pyplot as plt</a:t>
+            </a:r>
+          </a:p>
+          <a:p>
+            <a:pPr>
+              <a:defRPr sz="1200" b="0">
+                <a:solidFill>
+                  <a:srgbClr val="F8FAFC"/>
+                </a:solidFill>
+                <a:latin typeface="Courier New"/>
+              </a:defRPr>
+            </a:pPr>
+            <a:r>
+              <a:rPr sz="1200" b="0">
+                <a:solidFill>
+                  <a:srgbClr val="F8FAFC"/>
+                </a:solidFill>
+                <a:latin typeface="Courier New"/>
+              </a:rPr>
+              <a:t> </a:t>
+            </a:r>
+          </a:p>
+          <a:p>
+            <a:pPr>
+              <a:defRPr sz="1200" b="0">
+                <a:solidFill>
+                  <a:srgbClr val="F8FAFC"/>
+                </a:solidFill>
+                <a:latin typeface="Courier New"/>
+              </a:defRPr>
+            </a:pPr>
+            <a:r>
+              <a:rPr sz="1200" b="0">
+                <a:solidFill>
+                  <a:srgbClr val="F8FAFC"/>
+                </a:solidFill>
+                <a:latin typeface="Courier New"/>
+              </a:rPr>
+              <a:t>rng = np.random.default_rng(42)</a:t>
+            </a:r>
+          </a:p>
+          <a:p>
+            <a:pPr>
+              <a:defRPr sz="1200" b="0">
+                <a:solidFill>
+                  <a:srgbClr val="F8FAFC"/>
+                </a:solidFill>
+                <a:latin typeface="Courier New"/>
+              </a:defRPr>
+            </a:pPr>
+            <a:r>
+              <a:rPr sz="1200" b="0">
+                <a:solidFill>
+                  <a:srgbClr val="F8FAFC"/>
+                </a:solidFill>
+                <a:latin typeface="Courier New"/>
+              </a:rPr>
+              <a:t> </a:t>
+            </a:r>
+          </a:p>
+          <a:p>
+            <a:pPr>
+              <a:defRPr sz="1200" b="0">
+                <a:solidFill>
+                  <a:srgbClr val="F8FAFC"/>
+                </a:solidFill>
+                <a:latin typeface="Courier New"/>
+              </a:defRPr>
+            </a:pPr>
+            <a:r>
+              <a:rPr sz="1200" b="0">
+                <a:solidFill>
+                  <a:srgbClr val="F8FAFC"/>
+                </a:solidFill>
+                <a:latin typeface="Courier New"/>
+              </a:rPr>
+              <a:t>total_bill = rng.normal(21.5, 8, 200)</a:t>
+            </a:r>
+          </a:p>
+          <a:p>
+            <a:pPr>
+              <a:defRPr sz="1200" b="0">
+                <a:solidFill>
+                  <a:srgbClr val="F8FAFC"/>
+                </a:solidFill>
+                <a:latin typeface="Courier New"/>
+              </a:defRPr>
+            </a:pPr>
+            <a:r>
+              <a:rPr sz="1200" b="0">
+                <a:solidFill>
+                  <a:srgbClr val="F8FAFC"/>
+                </a:solidFill>
+                <a:latin typeface="Courier New"/>
+              </a:rPr>
+              <a:t>res = stats.ttest_1samp(total_bill, popmean=20)</a:t>
+            </a:r>
+          </a:p>
+          <a:p>
+            <a:pPr>
+              <a:defRPr sz="1200" b="0">
+                <a:solidFill>
+                  <a:srgbClr val="F8FAFC"/>
+                </a:solidFill>
+                <a:latin typeface="Courier New"/>
+              </a:defRPr>
+            </a:pPr>
+            <a:r>
+              <a:rPr sz="1200" b="0">
+                <a:solidFill>
+                  <a:srgbClr val="F8FAFC"/>
+                </a:solidFill>
+                <a:latin typeface="Courier New"/>
+              </a:rPr>
+              <a:t>ci = res.confidence_interval(0.95)</a:t>
+            </a:r>
+          </a:p>
+          <a:p>
+            <a:pPr>
+              <a:defRPr sz="1200" b="0">
+                <a:solidFill>
+                  <a:srgbClr val="F8FAFC"/>
+                </a:solidFill>
+                <a:latin typeface="Courier New"/>
+              </a:defRPr>
+            </a:pPr>
+            <a:r>
+              <a:rPr sz="1200" b="0">
+                <a:solidFill>
+                  <a:srgbClr val="F8FAFC"/>
+                </a:solidFill>
+                <a:latin typeface="Courier New"/>
+              </a:rPr>
+              <a:t>print("H0: μ=20  vs  H1: μ≠20")</a:t>
+            </a:r>
+          </a:p>
+          <a:p>
+            <a:pPr>
+              <a:defRPr sz="1200" b="0">
+                <a:solidFill>
+                  <a:srgbClr val="F8FAFC"/>
+                </a:solidFill>
+                <a:latin typeface="Courier New"/>
+              </a:defRPr>
+            </a:pPr>
+            <a:r>
+              <a:rPr sz="1200" b="0">
+                <a:solidFill>
+                  <a:srgbClr val="F8FAFC"/>
+                </a:solidFill>
+                <a:latin typeface="Courier New"/>
+              </a:rPr>
+              <a:t>print(f"t={res.statistic:.3f}  p={res.pvalue:.4f}  IC95%=({ci.low:.2f}, {ci.high:.2f})")</a:t>
+            </a:r>
+          </a:p>
+          <a:p>
+            <a:pPr>
+              <a:defRPr sz="1200" b="0">
+                <a:solidFill>
+                  <a:srgbClr val="F8FAFC"/>
+                </a:solidFill>
+                <a:latin typeface="Courier New"/>
+              </a:defRPr>
+            </a:pPr>
+            <a:r>
+              <a:rPr sz="1200" b="0">
+                <a:solidFill>
+                  <a:srgbClr val="F8FAFC"/>
+                </a:solidFill>
+                <a:latin typeface="Courier New"/>
+              </a:rPr>
+              <a:t>print("Rechazo H0" if res.pvalue &lt; 0.05 else "No rechazo H0")</a:t>
+            </a:r>
+          </a:p>
+          <a:p>
+            <a:pPr>
+              <a:defRPr sz="1200" b="0">
+                <a:solidFill>
+                  <a:srgbClr val="F8FAFC"/>
+                </a:solidFill>
+                <a:latin typeface="Courier New"/>
+              </a:defRPr>
+            </a:pPr>
+            <a:r>
+              <a:rPr sz="1200" b="0">
+                <a:solidFill>
+                  <a:srgbClr val="F8FAFC"/>
+                </a:solidFill>
+                <a:latin typeface="Courier New"/>
+              </a:rPr>
+              <a:t>excluye_20 = ci.low &gt; 20 or ci.high &lt; 20</a:t>
+            </a:r>
+          </a:p>
+          <a:p>
+            <a:pPr>
+              <a:defRPr sz="1200" b="0">
+                <a:solidFill>
+                  <a:srgbClr val="F8FAFC"/>
+                </a:solidFill>
+                <a:latin typeface="Courier New"/>
+              </a:defRPr>
+            </a:pPr>
+            <a:r>
+              <a:rPr sz="1200" b="0">
+                <a:solidFill>
+                  <a:srgbClr val="F8FAFC"/>
+                </a:solidFill>
+                <a:latin typeface="Courier New"/>
+              </a:rPr>
+              <a:t>assert (res.pvalue &lt; 0.05) == excluye_20, "p-value e IC deben concordar"</a:t>
             </a:r>
           </a:p>
         </p:txBody>
@@ -9378,7 +9625,7 @@
                 </a:solidFill>
                 <a:latin typeface="Segoe UI"/>
               </a:rPr>
-              <a:t>Primer bloque ejecutable del notebook.</a:t>
+              <a:t>H₀: las variables son independientes. Simulamos supervivencia dependiente de la clase (estilo Titanic).</a:t>
             </a:r>
           </a:p>
         </p:txBody>
@@ -9465,7 +9712,311 @@
                 </a:solidFill>
                 <a:latin typeface="Courier New"/>
               </a:rPr>
-              <a:t># Imports y configuración inicial</a:t>
+              <a:t>import numpy as np</a:t>
+            </a:r>
+          </a:p>
+          <a:p>
+            <a:pPr>
+              <a:defRPr sz="1200" b="0">
+                <a:solidFill>
+                  <a:srgbClr val="F8FAFC"/>
+                </a:solidFill>
+                <a:latin typeface="Courier New"/>
+              </a:defRPr>
+            </a:pPr>
+            <a:r>
+              <a:rPr sz="1200" b="0">
+                <a:solidFill>
+                  <a:srgbClr val="F8FAFC"/>
+                </a:solidFill>
+                <a:latin typeface="Courier New"/>
+              </a:rPr>
+              <a:t>import pandas as pd</a:t>
+            </a:r>
+          </a:p>
+          <a:p>
+            <a:pPr>
+              <a:defRPr sz="1200" b="0">
+                <a:solidFill>
+                  <a:srgbClr val="F8FAFC"/>
+                </a:solidFill>
+                <a:latin typeface="Courier New"/>
+              </a:defRPr>
+            </a:pPr>
+            <a:r>
+              <a:rPr sz="1200" b="0">
+                <a:solidFill>
+                  <a:srgbClr val="F8FAFC"/>
+                </a:solidFill>
+                <a:latin typeface="Courier New"/>
+              </a:rPr>
+              <a:t>from scipy import stats</a:t>
+            </a:r>
+          </a:p>
+          <a:p>
+            <a:pPr>
+              <a:defRPr sz="1200" b="0">
+                <a:solidFill>
+                  <a:srgbClr val="F8FAFC"/>
+                </a:solidFill>
+                <a:latin typeface="Courier New"/>
+              </a:defRPr>
+            </a:pPr>
+            <a:r>
+              <a:rPr sz="1200" b="0">
+                <a:solidFill>
+                  <a:srgbClr val="F8FAFC"/>
+                </a:solidFill>
+                <a:latin typeface="Courier New"/>
+              </a:rPr>
+              <a:t>import matplotlib.pyplot as plt</a:t>
+            </a:r>
+          </a:p>
+          <a:p>
+            <a:pPr>
+              <a:defRPr sz="1200" b="0">
+                <a:solidFill>
+                  <a:srgbClr val="F8FAFC"/>
+                </a:solidFill>
+                <a:latin typeface="Courier New"/>
+              </a:defRPr>
+            </a:pPr>
+            <a:r>
+              <a:rPr sz="1200" b="0">
+                <a:solidFill>
+                  <a:srgbClr val="F8FAFC"/>
+                </a:solidFill>
+                <a:latin typeface="Courier New"/>
+              </a:rPr>
+              <a:t> </a:t>
+            </a:r>
+          </a:p>
+          <a:p>
+            <a:pPr>
+              <a:defRPr sz="1200" b="0">
+                <a:solidFill>
+                  <a:srgbClr val="F8FAFC"/>
+                </a:solidFill>
+                <a:latin typeface="Courier New"/>
+              </a:defRPr>
+            </a:pPr>
+            <a:r>
+              <a:rPr sz="1200" b="0">
+                <a:solidFill>
+                  <a:srgbClr val="F8FAFC"/>
+                </a:solidFill>
+                <a:latin typeface="Courier New"/>
+              </a:rPr>
+              <a:t>rng = np.random.default_rng(42)</a:t>
+            </a:r>
+          </a:p>
+          <a:p>
+            <a:pPr>
+              <a:defRPr sz="1200" b="0">
+                <a:solidFill>
+                  <a:srgbClr val="F8FAFC"/>
+                </a:solidFill>
+                <a:latin typeface="Courier New"/>
+              </a:defRPr>
+            </a:pPr>
+            <a:r>
+              <a:rPr sz="1200" b="0">
+                <a:solidFill>
+                  <a:srgbClr val="F8FAFC"/>
+                </a:solidFill>
+                <a:latin typeface="Courier New"/>
+              </a:rPr>
+              <a:t> </a:t>
+            </a:r>
+          </a:p>
+          <a:p>
+            <a:pPr>
+              <a:defRPr sz="1200" b="0">
+                <a:solidFill>
+                  <a:srgbClr val="F8FAFC"/>
+                </a:solidFill>
+                <a:latin typeface="Courier New"/>
+              </a:defRPr>
+            </a:pPr>
+            <a:r>
+              <a:rPr sz="1200" b="0">
+                <a:solidFill>
+                  <a:srgbClr val="F8FAFC"/>
+                </a:solidFill>
+                <a:latin typeface="Courier New"/>
+              </a:rPr>
+              <a:t>n = 1200</a:t>
+            </a:r>
+          </a:p>
+          <a:p>
+            <a:pPr>
+              <a:defRPr sz="1200" b="0">
+                <a:solidFill>
+                  <a:srgbClr val="F8FAFC"/>
+                </a:solidFill>
+                <a:latin typeface="Courier New"/>
+              </a:defRPr>
+            </a:pPr>
+            <a:r>
+              <a:rPr sz="1200" b="0">
+                <a:solidFill>
+                  <a:srgbClr val="F8FAFC"/>
+                </a:solidFill>
+                <a:latin typeface="Courier New"/>
+              </a:rPr>
+              <a:t>clase = rng.choice(["1a", "2a", "3a"], size=n, p=[0.25, 0.20, 0.55])</a:t>
+            </a:r>
+          </a:p>
+          <a:p>
+            <a:pPr>
+              <a:defRPr sz="1200" b="0">
+                <a:solidFill>
+                  <a:srgbClr val="F8FAFC"/>
+                </a:solidFill>
+                <a:latin typeface="Courier New"/>
+              </a:defRPr>
+            </a:pPr>
+            <a:r>
+              <a:rPr sz="1200" b="0">
+                <a:solidFill>
+                  <a:srgbClr val="F8FAFC"/>
+                </a:solidFill>
+                <a:latin typeface="Courier New"/>
+              </a:rPr>
+              <a:t>p_surv = {"1a": 0.62, "2a": 0.43, "3a": 0.24}</a:t>
+            </a:r>
+          </a:p>
+          <a:p>
+            <a:pPr>
+              <a:defRPr sz="1200" b="0">
+                <a:solidFill>
+                  <a:srgbClr val="F8FAFC"/>
+                </a:solidFill>
+                <a:latin typeface="Courier New"/>
+              </a:defRPr>
+            </a:pPr>
+            <a:r>
+              <a:rPr sz="1200" b="0">
+                <a:solidFill>
+                  <a:srgbClr val="F8FAFC"/>
+                </a:solidFill>
+                <a:latin typeface="Courier New"/>
+              </a:rPr>
+              <a:t>survived = np.array([rng.random() &lt; p_surv[c] for c in clase]).astype(int)</a:t>
+            </a:r>
+          </a:p>
+          <a:p>
+            <a:pPr>
+              <a:defRPr sz="1200" b="0">
+                <a:solidFill>
+                  <a:srgbClr val="F8FAFC"/>
+                </a:solidFill>
+                <a:latin typeface="Courier New"/>
+              </a:defRPr>
+            </a:pPr>
+            <a:r>
+              <a:rPr sz="1200" b="0">
+                <a:solidFill>
+                  <a:srgbClr val="F8FAFC"/>
+                </a:solidFill>
+                <a:latin typeface="Courier New"/>
+              </a:rPr>
+              <a:t> </a:t>
+            </a:r>
+          </a:p>
+          <a:p>
+            <a:pPr>
+              <a:defRPr sz="1200" b="0">
+                <a:solidFill>
+                  <a:srgbClr val="F8FAFC"/>
+                </a:solidFill>
+                <a:latin typeface="Courier New"/>
+              </a:defRPr>
+            </a:pPr>
+            <a:r>
+              <a:rPr sz="1200" b="0">
+                <a:solidFill>
+                  <a:srgbClr val="F8FAFC"/>
+                </a:solidFill>
+                <a:latin typeface="Courier New"/>
+              </a:rPr>
+              <a:t>tabla = pd.crosstab(pd.Series(survived, name="survived"), pd.Series(clase, name="clase"))</a:t>
+            </a:r>
+          </a:p>
+          <a:p>
+            <a:pPr>
+              <a:defRPr sz="1200" b="0">
+                <a:solidFill>
+                  <a:srgbClr val="F8FAFC"/>
+                </a:solidFill>
+                <a:latin typeface="Courier New"/>
+              </a:defRPr>
+            </a:pPr>
+            <a:r>
+              <a:rPr sz="1200" b="0">
+                <a:solidFill>
+                  <a:srgbClr val="F8FAFC"/>
+                </a:solidFill>
+                <a:latin typeface="Courier New"/>
+              </a:rPr>
+              <a:t>print(tabla)</a:t>
+            </a:r>
+          </a:p>
+          <a:p>
+            <a:pPr>
+              <a:defRPr sz="1200" b="0">
+                <a:solidFill>
+                  <a:srgbClr val="F8FAFC"/>
+                </a:solidFill>
+                <a:latin typeface="Courier New"/>
+              </a:defRPr>
+            </a:pPr>
+            <a:r>
+              <a:rPr sz="1200" b="0">
+                <a:solidFill>
+                  <a:srgbClr val="F8FAFC"/>
+                </a:solidFill>
+                <a:latin typeface="Courier New"/>
+              </a:rPr>
+              <a:t>chi2, p, dof, expected = stats.chi2_contingency(tabla)</a:t>
+            </a:r>
+          </a:p>
+          <a:p>
+            <a:pPr>
+              <a:defRPr sz="1200" b="0">
+                <a:solidFill>
+                  <a:srgbClr val="F8FAFC"/>
+                </a:solidFill>
+                <a:latin typeface="Courier New"/>
+              </a:defRPr>
+            </a:pPr>
+            <a:r>
+              <a:rPr sz="1200" b="0">
+                <a:solidFill>
+                  <a:srgbClr val="F8FAFC"/>
+                </a:solidFill>
+                <a:latin typeface="Courier New"/>
+              </a:rPr>
+              <a:t>print(f"\nχ²={chi2:.2f}  dof={dof}  p={p:.2e}")</a:t>
+            </a:r>
+          </a:p>
+          <a:p>
+            <a:pPr>
+              <a:defRPr sz="1200" b="0">
+                <a:solidFill>
+                  <a:srgbClr val="F8FAFC"/>
+                </a:solidFill>
+                <a:latin typeface="Courier New"/>
+              </a:defRPr>
+            </a:pPr>
+            <a:r>
+              <a:rPr sz="1200" b="0">
+                <a:solidFill>
+                  <a:srgbClr val="F8FAFC"/>
+                </a:solidFill>
+                <a:latin typeface="Courier New"/>
+              </a:rPr>
+              <a:t>assert p &lt; 0.001</a:t>
             </a:r>
           </a:p>
         </p:txBody>
@@ -11412,7 +11963,7 @@
                 </a:solidFill>
                 <a:latin typeface="Segoe UI"/>
               </a:rPr>
-              <a:t>Primer bloque ejecutable del notebook.</a:t>
+              <a:t>H₀: μ₁ = μ₂ = μ₃. Simulamos la masa corporal de 3 especies de pingüinos. F = MS_between / MS_within.</a:t>
             </a:r>
           </a:p>
         </p:txBody>
@@ -11499,7 +12050,349 @@
                 </a:solidFill>
                 <a:latin typeface="Courier New"/>
               </a:rPr>
-              <a:t># Imports y configuración inicial</a:t>
+              <a:t>import numpy as np</a:t>
+            </a:r>
+          </a:p>
+          <a:p>
+            <a:pPr>
+              <a:defRPr sz="1200" b="0">
+                <a:solidFill>
+                  <a:srgbClr val="F8FAFC"/>
+                </a:solidFill>
+                <a:latin typeface="Courier New"/>
+              </a:defRPr>
+            </a:pPr>
+            <a:r>
+              <a:rPr sz="1200" b="0">
+                <a:solidFill>
+                  <a:srgbClr val="F8FAFC"/>
+                </a:solidFill>
+                <a:latin typeface="Courier New"/>
+              </a:rPr>
+              <a:t>import pandas as pd</a:t>
+            </a:r>
+          </a:p>
+          <a:p>
+            <a:pPr>
+              <a:defRPr sz="1200" b="0">
+                <a:solidFill>
+                  <a:srgbClr val="F8FAFC"/>
+                </a:solidFill>
+                <a:latin typeface="Courier New"/>
+              </a:defRPr>
+            </a:pPr>
+            <a:r>
+              <a:rPr sz="1200" b="0">
+                <a:solidFill>
+                  <a:srgbClr val="F8FAFC"/>
+                </a:solidFill>
+                <a:latin typeface="Courier New"/>
+              </a:rPr>
+              <a:t>from scipy import stats</a:t>
+            </a:r>
+          </a:p>
+          <a:p>
+            <a:pPr>
+              <a:defRPr sz="1200" b="0">
+                <a:solidFill>
+                  <a:srgbClr val="F8FAFC"/>
+                </a:solidFill>
+                <a:latin typeface="Courier New"/>
+              </a:defRPr>
+            </a:pPr>
+            <a:r>
+              <a:rPr sz="1200" b="0">
+                <a:solidFill>
+                  <a:srgbClr val="F8FAFC"/>
+                </a:solidFill>
+                <a:latin typeface="Courier New"/>
+              </a:rPr>
+              <a:t>import statsmodels.formula.api as smf</a:t>
+            </a:r>
+          </a:p>
+          <a:p>
+            <a:pPr>
+              <a:defRPr sz="1200" b="0">
+                <a:solidFill>
+                  <a:srgbClr val="F8FAFC"/>
+                </a:solidFill>
+                <a:latin typeface="Courier New"/>
+              </a:defRPr>
+            </a:pPr>
+            <a:r>
+              <a:rPr sz="1200" b="0">
+                <a:solidFill>
+                  <a:srgbClr val="F8FAFC"/>
+                </a:solidFill>
+                <a:latin typeface="Courier New"/>
+              </a:rPr>
+              <a:t>from statsmodels.stats.anova import anova_lm</a:t>
+            </a:r>
+          </a:p>
+          <a:p>
+            <a:pPr>
+              <a:defRPr sz="1200" b="0">
+                <a:solidFill>
+                  <a:srgbClr val="F8FAFC"/>
+                </a:solidFill>
+                <a:latin typeface="Courier New"/>
+              </a:defRPr>
+            </a:pPr>
+            <a:r>
+              <a:rPr sz="1200" b="0">
+                <a:solidFill>
+                  <a:srgbClr val="F8FAFC"/>
+                </a:solidFill>
+                <a:latin typeface="Courier New"/>
+              </a:rPr>
+              <a:t>from statsmodels.stats.multicomp import pairwise_tukeyhsd</a:t>
+            </a:r>
+          </a:p>
+          <a:p>
+            <a:pPr>
+              <a:defRPr sz="1200" b="0">
+                <a:solidFill>
+                  <a:srgbClr val="F8FAFC"/>
+                </a:solidFill>
+                <a:latin typeface="Courier New"/>
+              </a:defRPr>
+            </a:pPr>
+            <a:r>
+              <a:rPr sz="1200" b="0">
+                <a:solidFill>
+                  <a:srgbClr val="F8FAFC"/>
+                </a:solidFill>
+                <a:latin typeface="Courier New"/>
+              </a:rPr>
+              <a:t>import matplotlib.pyplot as plt</a:t>
+            </a:r>
+          </a:p>
+          <a:p>
+            <a:pPr>
+              <a:defRPr sz="1200" b="0">
+                <a:solidFill>
+                  <a:srgbClr val="F8FAFC"/>
+                </a:solidFill>
+                <a:latin typeface="Courier New"/>
+              </a:defRPr>
+            </a:pPr>
+            <a:r>
+              <a:rPr sz="1200" b="0">
+                <a:solidFill>
+                  <a:srgbClr val="F8FAFC"/>
+                </a:solidFill>
+                <a:latin typeface="Courier New"/>
+              </a:rPr>
+              <a:t> </a:t>
+            </a:r>
+          </a:p>
+          <a:p>
+            <a:pPr>
+              <a:defRPr sz="1200" b="0">
+                <a:solidFill>
+                  <a:srgbClr val="F8FAFC"/>
+                </a:solidFill>
+                <a:latin typeface="Courier New"/>
+              </a:defRPr>
+            </a:pPr>
+            <a:r>
+              <a:rPr sz="1200" b="0">
+                <a:solidFill>
+                  <a:srgbClr val="F8FAFC"/>
+                </a:solidFill>
+                <a:latin typeface="Courier New"/>
+              </a:rPr>
+              <a:t>rng = np.random.default_rng(42)</a:t>
+            </a:r>
+          </a:p>
+          <a:p>
+            <a:pPr>
+              <a:defRPr sz="1200" b="0">
+                <a:solidFill>
+                  <a:srgbClr val="F8FAFC"/>
+                </a:solidFill>
+                <a:latin typeface="Courier New"/>
+              </a:defRPr>
+            </a:pPr>
+            <a:r>
+              <a:rPr sz="1200" b="0">
+                <a:solidFill>
+                  <a:srgbClr val="F8FAFC"/>
+                </a:solidFill>
+                <a:latin typeface="Courier New"/>
+              </a:rPr>
+              <a:t> </a:t>
+            </a:r>
+          </a:p>
+          <a:p>
+            <a:pPr>
+              <a:defRPr sz="1200" b="0">
+                <a:solidFill>
+                  <a:srgbClr val="F8FAFC"/>
+                </a:solidFill>
+                <a:latin typeface="Courier New"/>
+              </a:defRPr>
+            </a:pPr>
+            <a:r>
+              <a:rPr sz="1200" b="0">
+                <a:solidFill>
+                  <a:srgbClr val="F8FAFC"/>
+                </a:solidFill>
+                <a:latin typeface="Courier New"/>
+              </a:rPr>
+              <a:t>adelie    = rng.normal(3700, 460, 150)</a:t>
+            </a:r>
+          </a:p>
+          <a:p>
+            <a:pPr>
+              <a:defRPr sz="1200" b="0">
+                <a:solidFill>
+                  <a:srgbClr val="F8FAFC"/>
+                </a:solidFill>
+                <a:latin typeface="Courier New"/>
+              </a:defRPr>
+            </a:pPr>
+            <a:r>
+              <a:rPr sz="1200" b="0">
+                <a:solidFill>
+                  <a:srgbClr val="F8FAFC"/>
+                </a:solidFill>
+                <a:latin typeface="Courier New"/>
+              </a:rPr>
+              <a:t>gentoo    = rng.normal(5080, 500, 120)</a:t>
+            </a:r>
+          </a:p>
+          <a:p>
+            <a:pPr>
+              <a:defRPr sz="1200" b="0">
+                <a:solidFill>
+                  <a:srgbClr val="F8FAFC"/>
+                </a:solidFill>
+                <a:latin typeface="Courier New"/>
+              </a:defRPr>
+            </a:pPr>
+            <a:r>
+              <a:rPr sz="1200" b="0">
+                <a:solidFill>
+                  <a:srgbClr val="F8FAFC"/>
+                </a:solidFill>
+                <a:latin typeface="Courier New"/>
+              </a:rPr>
+              <a:t>chinstrap = rng.normal(3730, 380, 68)</a:t>
+            </a:r>
+          </a:p>
+          <a:p>
+            <a:pPr>
+              <a:defRPr sz="1200" b="0">
+                <a:solidFill>
+                  <a:srgbClr val="F8FAFC"/>
+                </a:solidFill>
+                <a:latin typeface="Courier New"/>
+              </a:defRPr>
+            </a:pPr>
+            <a:r>
+              <a:rPr sz="1200" b="0">
+                <a:solidFill>
+                  <a:srgbClr val="F8FAFC"/>
+                </a:solidFill>
+                <a:latin typeface="Courier New"/>
+              </a:rPr>
+              <a:t>F, p = stats.f_oneway(adelie, gentoo, chinstrap)</a:t>
+            </a:r>
+          </a:p>
+          <a:p>
+            <a:pPr>
+              <a:defRPr sz="1200" b="0">
+                <a:solidFill>
+                  <a:srgbClr val="F8FAFC"/>
+                </a:solidFill>
+                <a:latin typeface="Courier New"/>
+              </a:defRPr>
+            </a:pPr>
+            <a:r>
+              <a:rPr sz="1200" b="0">
+                <a:solidFill>
+                  <a:srgbClr val="F8FAFC"/>
+                </a:solidFill>
+                <a:latin typeface="Courier New"/>
+              </a:rPr>
+              <a:t>k = 3</a:t>
+            </a:r>
+          </a:p>
+          <a:p>
+            <a:pPr>
+              <a:defRPr sz="1200" b="0">
+                <a:solidFill>
+                  <a:srgbClr val="F8FAFC"/>
+                </a:solidFill>
+                <a:latin typeface="Courier New"/>
+              </a:defRPr>
+            </a:pPr>
+            <a:r>
+              <a:rPr sz="1200" b="0">
+                <a:solidFill>
+                  <a:srgbClr val="F8FAFC"/>
+                </a:solidFill>
+                <a:latin typeface="Courier New"/>
+              </a:rPr>
+              <a:t>N = len(adelie) + len(gentoo) + len(chinstrap)</a:t>
+            </a:r>
+          </a:p>
+          <a:p>
+            <a:pPr>
+              <a:defRPr sz="1200" b="0">
+                <a:solidFill>
+                  <a:srgbClr val="F8FAFC"/>
+                </a:solidFill>
+                <a:latin typeface="Courier New"/>
+              </a:defRPr>
+            </a:pPr>
+            <a:r>
+              <a:rPr sz="1200" b="0">
+                <a:solidFill>
+                  <a:srgbClr val="F8FAFC"/>
+                </a:solidFill>
+                <a:latin typeface="Courier New"/>
+              </a:rPr>
+              <a:t>print(f"One-way ANOVA: F={F:.2f}  p={p:.2e}")</a:t>
+            </a:r>
+          </a:p>
+          <a:p>
+            <a:pPr>
+              <a:defRPr sz="1200" b="0">
+                <a:solidFill>
+                  <a:srgbClr val="F8FAFC"/>
+                </a:solidFill>
+                <a:latin typeface="Courier New"/>
+              </a:defRPr>
+            </a:pPr>
+            <a:r>
+              <a:rPr sz="1200" b="0">
+                <a:solidFill>
+                  <a:srgbClr val="F8FAFC"/>
+                </a:solidFill>
+                <a:latin typeface="Courier New"/>
+              </a:rPr>
+              <a:t>print(f"gl_between={k-1}  gl_within={N-k}")</a:t>
+            </a:r>
+          </a:p>
+          <a:p>
+            <a:pPr>
+              <a:defRPr sz="1200" b="0">
+                <a:solidFill>
+                  <a:srgbClr val="F8FAFC"/>
+                </a:solidFill>
+                <a:latin typeface="Courier New"/>
+              </a:defRPr>
+            </a:pPr>
+            <a:r>
+              <a:rPr sz="1200" b="0">
+                <a:solidFill>
+                  <a:srgbClr val="F8FAFC"/>
+                </a:solidFill>
+                <a:latin typeface="Courier New"/>
+              </a:rPr>
+              <a:t>assert p &lt; 0.001</a:t>
             </a:r>
           </a:p>
         </p:txBody>
@@ -13802,7 +14695,7 @@
                 </a:solidFill>
                 <a:latin typeface="Segoe UI"/>
               </a:rPr>
-              <a:t>Primer bloque ejecutable del notebook.</a:t>
+              <a:t>H₀: P(X &gt; Y) = 0.5. Trabaja sobre rangos, no sobre medias. El effect size es la rank-biserial r = 1 - 2U/(n₁·n₂).</a:t>
             </a:r>
           </a:p>
         </p:txBody>
@@ -13889,7 +14782,273 @@
                 </a:solidFill>
                 <a:latin typeface="Courier New"/>
               </a:rPr>
-              <a:t># Imports y configuración inicial</a:t>
+              <a:t>import numpy as np</a:t>
+            </a:r>
+          </a:p>
+          <a:p>
+            <a:pPr>
+              <a:defRPr sz="1200" b="0">
+                <a:solidFill>
+                  <a:srgbClr val="F8FAFC"/>
+                </a:solidFill>
+                <a:latin typeface="Courier New"/>
+              </a:defRPr>
+            </a:pPr>
+            <a:r>
+              <a:rPr sz="1200" b="0">
+                <a:solidFill>
+                  <a:srgbClr val="F8FAFC"/>
+                </a:solidFill>
+                <a:latin typeface="Courier New"/>
+              </a:rPr>
+              <a:t>from scipy import stats</a:t>
+            </a:r>
+          </a:p>
+          <a:p>
+            <a:pPr>
+              <a:defRPr sz="1200" b="0">
+                <a:solidFill>
+                  <a:srgbClr val="F8FAFC"/>
+                </a:solidFill>
+                <a:latin typeface="Courier New"/>
+              </a:defRPr>
+            </a:pPr>
+            <a:r>
+              <a:rPr sz="1200" b="0">
+                <a:solidFill>
+                  <a:srgbClr val="F8FAFC"/>
+                </a:solidFill>
+                <a:latin typeface="Courier New"/>
+              </a:rPr>
+              <a:t>from statsmodels.stats.multitest import multipletests</a:t>
+            </a:r>
+          </a:p>
+          <a:p>
+            <a:pPr>
+              <a:defRPr sz="1200" b="0">
+                <a:solidFill>
+                  <a:srgbClr val="F8FAFC"/>
+                </a:solidFill>
+                <a:latin typeface="Courier New"/>
+              </a:defRPr>
+            </a:pPr>
+            <a:r>
+              <a:rPr sz="1200" b="0">
+                <a:solidFill>
+                  <a:srgbClr val="F8FAFC"/>
+                </a:solidFill>
+                <a:latin typeface="Courier New"/>
+              </a:rPr>
+              <a:t>import matplotlib.pyplot as plt</a:t>
+            </a:r>
+          </a:p>
+          <a:p>
+            <a:pPr>
+              <a:defRPr sz="1200" b="0">
+                <a:solidFill>
+                  <a:srgbClr val="F8FAFC"/>
+                </a:solidFill>
+                <a:latin typeface="Courier New"/>
+              </a:defRPr>
+            </a:pPr>
+            <a:r>
+              <a:rPr sz="1200" b="0">
+                <a:solidFill>
+                  <a:srgbClr val="F8FAFC"/>
+                </a:solidFill>
+                <a:latin typeface="Courier New"/>
+              </a:rPr>
+              <a:t> </a:t>
+            </a:r>
+          </a:p>
+          <a:p>
+            <a:pPr>
+              <a:defRPr sz="1200" b="0">
+                <a:solidFill>
+                  <a:srgbClr val="F8FAFC"/>
+                </a:solidFill>
+                <a:latin typeface="Courier New"/>
+              </a:defRPr>
+            </a:pPr>
+            <a:r>
+              <a:rPr sz="1200" b="0">
+                <a:solidFill>
+                  <a:srgbClr val="F8FAFC"/>
+                </a:solidFill>
+                <a:latin typeface="Courier New"/>
+              </a:rPr>
+              <a:t>rng = np.random.default_rng(42)</a:t>
+            </a:r>
+          </a:p>
+          <a:p>
+            <a:pPr>
+              <a:defRPr sz="1200" b="0">
+                <a:solidFill>
+                  <a:srgbClr val="F8FAFC"/>
+                </a:solidFill>
+                <a:latin typeface="Courier New"/>
+              </a:defRPr>
+            </a:pPr>
+            <a:r>
+              <a:rPr sz="1200" b="0">
+                <a:solidFill>
+                  <a:srgbClr val="F8FAFC"/>
+                </a:solidFill>
+                <a:latin typeface="Courier New"/>
+              </a:rPr>
+              <a:t> </a:t>
+            </a:r>
+          </a:p>
+          <a:p>
+            <a:pPr>
+              <a:defRPr sz="1200" b="0">
+                <a:solidFill>
+                  <a:srgbClr val="F8FAFC"/>
+                </a:solidFill>
+                <a:latin typeface="Courier New"/>
+              </a:defRPr>
+            </a:pPr>
+            <a:r>
+              <a:rPr sz="1200" b="0">
+                <a:solidFill>
+                  <a:srgbClr val="F8FAFC"/>
+                </a:solidFill>
+                <a:latin typeface="Courier New"/>
+              </a:rPr>
+              <a:t>a = rng.lognormal(1.0, 0.5, 80)     # asimétricos: el t-test es dudoso</a:t>
+            </a:r>
+          </a:p>
+          <a:p>
+            <a:pPr>
+              <a:defRPr sz="1200" b="0">
+                <a:solidFill>
+                  <a:srgbClr val="F8FAFC"/>
+                </a:solidFill>
+                <a:latin typeface="Courier New"/>
+              </a:defRPr>
+            </a:pPr>
+            <a:r>
+              <a:rPr sz="1200" b="0">
+                <a:solidFill>
+                  <a:srgbClr val="F8FAFC"/>
+                </a:solidFill>
+                <a:latin typeface="Courier New"/>
+              </a:rPr>
+              <a:t>b = rng.lognormal(1.25, 0.5, 90)</a:t>
+            </a:r>
+          </a:p>
+          <a:p>
+            <a:pPr>
+              <a:defRPr sz="1200" b="0">
+                <a:solidFill>
+                  <a:srgbClr val="F8FAFC"/>
+                </a:solidFill>
+                <a:latin typeface="Courier New"/>
+              </a:defRPr>
+            </a:pPr>
+            <a:r>
+              <a:rPr sz="1200" b="0">
+                <a:solidFill>
+                  <a:srgbClr val="F8FAFC"/>
+                </a:solidFill>
+                <a:latin typeface="Courier New"/>
+              </a:rPr>
+              <a:t>U, p = stats.mannwhitneyu(a, b, alternative="two-sided")</a:t>
+            </a:r>
+          </a:p>
+          <a:p>
+            <a:pPr>
+              <a:defRPr sz="1200" b="0">
+                <a:solidFill>
+                  <a:srgbClr val="F8FAFC"/>
+                </a:solidFill>
+                <a:latin typeface="Courier New"/>
+              </a:defRPr>
+            </a:pPr>
+            <a:r>
+              <a:rPr sz="1200" b="0">
+                <a:solidFill>
+                  <a:srgbClr val="F8FAFC"/>
+                </a:solidFill>
+                <a:latin typeface="Courier New"/>
+              </a:rPr>
+              <a:t>r_rb = 1 - 2 * U / (len(a) * len(b))</a:t>
+            </a:r>
+          </a:p>
+          <a:p>
+            <a:pPr>
+              <a:defRPr sz="1200" b="0">
+                <a:solidFill>
+                  <a:srgbClr val="F8FAFC"/>
+                </a:solidFill>
+                <a:latin typeface="Courier New"/>
+              </a:defRPr>
+            </a:pPr>
+            <a:r>
+              <a:rPr sz="1200" b="0">
+                <a:solidFill>
+                  <a:srgbClr val="F8FAFC"/>
+                </a:solidFill>
+                <a:latin typeface="Courier New"/>
+              </a:rPr>
+              <a:t>print(f"Mann-Whitney U={U:.0f}  p={p:.4f}")</a:t>
+            </a:r>
+          </a:p>
+          <a:p>
+            <a:pPr>
+              <a:defRPr sz="1200" b="0">
+                <a:solidFill>
+                  <a:srgbClr val="F8FAFC"/>
+                </a:solidFill>
+                <a:latin typeface="Courier New"/>
+              </a:defRPr>
+            </a:pPr>
+            <a:r>
+              <a:rPr sz="1200" b="0">
+                <a:solidFill>
+                  <a:srgbClr val="F8FAFC"/>
+                </a:solidFill>
+                <a:latin typeface="Courier New"/>
+              </a:rPr>
+              <a:t>print(f"rank-biserial r = {r_rb:.3f}")</a:t>
+            </a:r>
+          </a:p>
+          <a:p>
+            <a:pPr>
+              <a:defRPr sz="1200" b="0">
+                <a:solidFill>
+                  <a:srgbClr val="F8FAFC"/>
+                </a:solidFill>
+                <a:latin typeface="Courier New"/>
+              </a:defRPr>
+            </a:pPr>
+            <a:r>
+              <a:rPr sz="1200" b="0">
+                <a:solidFill>
+                  <a:srgbClr val="F8FAFC"/>
+                </a:solidFill>
+                <a:latin typeface="Courier New"/>
+              </a:rPr>
+              <a:t>print(f"medianas: a={np.median(a):.2f}  b={np.median(b):.2f}")</a:t>
+            </a:r>
+          </a:p>
+          <a:p>
+            <a:pPr>
+              <a:defRPr sz="1200" b="0">
+                <a:solidFill>
+                  <a:srgbClr val="F8FAFC"/>
+                </a:solidFill>
+                <a:latin typeface="Courier New"/>
+              </a:defRPr>
+            </a:pPr>
+            <a:r>
+              <a:rPr sz="1200" b="0">
+                <a:solidFill>
+                  <a:srgbClr val="F8FAFC"/>
+                </a:solidFill>
+                <a:latin typeface="Courier New"/>
+              </a:rPr>
+              <a:t>assert p &lt; 0.05</a:t>
             </a:r>
           </a:p>
         </p:txBody>
@@ -15858,7 +17017,7 @@
                 </a:solidFill>
                 <a:latin typeface="Segoe UI"/>
               </a:rPr>
-              <a:t>Primer bloque ejecutable del notebook.</a:t>
+              <a:t>Con m tests independientes y H₀ verdadera, P(≥1 falso positivo) = 1 - (1-α)^m. Lo verificamos por simulación.</a:t>
             </a:r>
           </a:p>
         </p:txBody>
@@ -15945,7 +17104,330 @@
                 </a:solidFill>
                 <a:latin typeface="Courier New"/>
               </a:rPr>
-              <a:t># Imports y configuración inicial</a:t>
+              <a:t>import numpy as np</a:t>
+            </a:r>
+          </a:p>
+          <a:p>
+            <a:pPr>
+              <a:defRPr sz="1200" b="0">
+                <a:solidFill>
+                  <a:srgbClr val="F8FAFC"/>
+                </a:solidFill>
+                <a:latin typeface="Courier New"/>
+              </a:defRPr>
+            </a:pPr>
+            <a:r>
+              <a:rPr sz="1200" b="0">
+                <a:solidFill>
+                  <a:srgbClr val="F8FAFC"/>
+                </a:solidFill>
+                <a:latin typeface="Courier New"/>
+              </a:rPr>
+              <a:t>import pandas as pd</a:t>
+            </a:r>
+          </a:p>
+          <a:p>
+            <a:pPr>
+              <a:defRPr sz="1200" b="0">
+                <a:solidFill>
+                  <a:srgbClr val="F8FAFC"/>
+                </a:solidFill>
+                <a:latin typeface="Courier New"/>
+              </a:defRPr>
+            </a:pPr>
+            <a:r>
+              <a:rPr sz="1200" b="0">
+                <a:solidFill>
+                  <a:srgbClr val="F8FAFC"/>
+                </a:solidFill>
+                <a:latin typeface="Courier New"/>
+              </a:rPr>
+              <a:t>from scipy import stats</a:t>
+            </a:r>
+          </a:p>
+          <a:p>
+            <a:pPr>
+              <a:defRPr sz="1200" b="0">
+                <a:solidFill>
+                  <a:srgbClr val="F8FAFC"/>
+                </a:solidFill>
+                <a:latin typeface="Courier New"/>
+              </a:defRPr>
+            </a:pPr>
+            <a:r>
+              <a:rPr sz="1200" b="0">
+                <a:solidFill>
+                  <a:srgbClr val="F8FAFC"/>
+                </a:solidFill>
+                <a:latin typeface="Courier New"/>
+              </a:rPr>
+              <a:t>from statsmodels.stats.multitest import multipletests</a:t>
+            </a:r>
+          </a:p>
+          <a:p>
+            <a:pPr>
+              <a:defRPr sz="1200" b="0">
+                <a:solidFill>
+                  <a:srgbClr val="F8FAFC"/>
+                </a:solidFill>
+                <a:latin typeface="Courier New"/>
+              </a:defRPr>
+            </a:pPr>
+            <a:r>
+              <a:rPr sz="1200" b="0">
+                <a:solidFill>
+                  <a:srgbClr val="F8FAFC"/>
+                </a:solidFill>
+                <a:latin typeface="Courier New"/>
+              </a:rPr>
+              <a:t>import matplotlib.pyplot as plt</a:t>
+            </a:r>
+          </a:p>
+          <a:p>
+            <a:pPr>
+              <a:defRPr sz="1200" b="0">
+                <a:solidFill>
+                  <a:srgbClr val="F8FAFC"/>
+                </a:solidFill>
+                <a:latin typeface="Courier New"/>
+              </a:defRPr>
+            </a:pPr>
+            <a:r>
+              <a:rPr sz="1200" b="0">
+                <a:solidFill>
+                  <a:srgbClr val="F8FAFC"/>
+                </a:solidFill>
+                <a:latin typeface="Courier New"/>
+              </a:rPr>
+              <a:t> </a:t>
+            </a:r>
+          </a:p>
+          <a:p>
+            <a:pPr>
+              <a:defRPr sz="1200" b="0">
+                <a:solidFill>
+                  <a:srgbClr val="F8FAFC"/>
+                </a:solidFill>
+                <a:latin typeface="Courier New"/>
+              </a:defRPr>
+            </a:pPr>
+            <a:r>
+              <a:rPr sz="1200" b="0">
+                <a:solidFill>
+                  <a:srgbClr val="F8FAFC"/>
+                </a:solidFill>
+                <a:latin typeface="Courier New"/>
+              </a:rPr>
+              <a:t>rng = np.random.default_rng(42)</a:t>
+            </a:r>
+          </a:p>
+          <a:p>
+            <a:pPr>
+              <a:defRPr sz="1200" b="0">
+                <a:solidFill>
+                  <a:srgbClr val="F8FAFC"/>
+                </a:solidFill>
+                <a:latin typeface="Courier New"/>
+              </a:defRPr>
+            </a:pPr>
+            <a:r>
+              <a:rPr sz="1200" b="0">
+                <a:solidFill>
+                  <a:srgbClr val="F8FAFC"/>
+                </a:solidFill>
+                <a:latin typeface="Courier New"/>
+              </a:rPr>
+              <a:t> </a:t>
+            </a:r>
+          </a:p>
+          <a:p>
+            <a:pPr>
+              <a:defRPr sz="1200" b="0">
+                <a:solidFill>
+                  <a:srgbClr val="F8FAFC"/>
+                </a:solidFill>
+                <a:latin typeface="Courier New"/>
+              </a:defRPr>
+            </a:pPr>
+            <a:r>
+              <a:rPr sz="1200" b="0">
+                <a:solidFill>
+                  <a:srgbClr val="F8FAFC"/>
+                </a:solidFill>
+                <a:latin typeface="Courier New"/>
+              </a:rPr>
+              <a:t>m = 20</a:t>
+            </a:r>
+          </a:p>
+          <a:p>
+            <a:pPr>
+              <a:defRPr sz="1200" b="0">
+                <a:solidFill>
+                  <a:srgbClr val="F8FAFC"/>
+                </a:solidFill>
+                <a:latin typeface="Courier New"/>
+              </a:defRPr>
+            </a:pPr>
+            <a:r>
+              <a:rPr sz="1200" b="0">
+                <a:solidFill>
+                  <a:srgbClr val="F8FAFC"/>
+                </a:solidFill>
+                <a:latin typeface="Courier New"/>
+              </a:rPr>
+              <a:t>n_exp = 2000</a:t>
+            </a:r>
+          </a:p>
+          <a:p>
+            <a:pPr>
+              <a:defRPr sz="1200" b="0">
+                <a:solidFill>
+                  <a:srgbClr val="F8FAFC"/>
+                </a:solidFill>
+                <a:latin typeface="Courier New"/>
+              </a:defRPr>
+            </a:pPr>
+            <a:r>
+              <a:rPr sz="1200" b="0">
+                <a:solidFill>
+                  <a:srgbClr val="F8FAFC"/>
+                </a:solidFill>
+                <a:latin typeface="Courier New"/>
+              </a:rPr>
+              <a:t>any_sig = 0</a:t>
+            </a:r>
+          </a:p>
+          <a:p>
+            <a:pPr>
+              <a:defRPr sz="1200" b="0">
+                <a:solidFill>
+                  <a:srgbClr val="F8FAFC"/>
+                </a:solidFill>
+                <a:latin typeface="Courier New"/>
+              </a:defRPr>
+            </a:pPr>
+            <a:r>
+              <a:rPr sz="1200" b="0">
+                <a:solidFill>
+                  <a:srgbClr val="F8FAFC"/>
+                </a:solidFill>
+                <a:latin typeface="Courier New"/>
+              </a:rPr>
+              <a:t>for _ in range(n_exp):</a:t>
+            </a:r>
+          </a:p>
+          <a:p>
+            <a:pPr>
+              <a:defRPr sz="1200" b="0">
+                <a:solidFill>
+                  <a:srgbClr val="F8FAFC"/>
+                </a:solidFill>
+                <a:latin typeface="Courier New"/>
+              </a:defRPr>
+            </a:pPr>
+            <a:r>
+              <a:rPr sz="1200" b="0">
+                <a:solidFill>
+                  <a:srgbClr val="F8FAFC"/>
+                </a:solidFill>
+                <a:latin typeface="Courier New"/>
+              </a:rPr>
+              <a:t>    pvals = [stats.ttest_ind(rng.normal(0, 1, 30), rng.normal(0, 1, 30)).pvalue for _ in range(m)]</a:t>
+            </a:r>
+          </a:p>
+          <a:p>
+            <a:pPr>
+              <a:defRPr sz="1200" b="0">
+                <a:solidFill>
+                  <a:srgbClr val="F8FAFC"/>
+                </a:solidFill>
+                <a:latin typeface="Courier New"/>
+              </a:defRPr>
+            </a:pPr>
+            <a:r>
+              <a:rPr sz="1200" b="0">
+                <a:solidFill>
+                  <a:srgbClr val="F8FAFC"/>
+                </a:solidFill>
+                <a:latin typeface="Courier New"/>
+              </a:rPr>
+              <a:t>    any_sig += (min(pvals) &lt; 0.05)</a:t>
+            </a:r>
+          </a:p>
+          <a:p>
+            <a:pPr>
+              <a:defRPr sz="1200" b="0">
+                <a:solidFill>
+                  <a:srgbClr val="F8FAFC"/>
+                </a:solidFill>
+                <a:latin typeface="Courier New"/>
+              </a:defRPr>
+            </a:pPr>
+            <a:r>
+              <a:rPr sz="1200" b="0">
+                <a:solidFill>
+                  <a:srgbClr val="F8FAFC"/>
+                </a:solidFill>
+                <a:latin typeface="Courier New"/>
+              </a:rPr>
+              <a:t>emp = any_sig / n_exp</a:t>
+            </a:r>
+          </a:p>
+          <a:p>
+            <a:pPr>
+              <a:defRPr sz="1200" b="0">
+                <a:solidFill>
+                  <a:srgbClr val="F8FAFC"/>
+                </a:solidFill>
+                <a:latin typeface="Courier New"/>
+              </a:defRPr>
+            </a:pPr>
+            <a:r>
+              <a:rPr sz="1200" b="0">
+                <a:solidFill>
+                  <a:srgbClr val="F8FAFC"/>
+                </a:solidFill>
+                <a:latin typeface="Courier New"/>
+              </a:rPr>
+              <a:t>theo = 1 - 0.95 ** m</a:t>
+            </a:r>
+          </a:p>
+          <a:p>
+            <a:pPr>
+              <a:defRPr sz="1200" b="0">
+                <a:solidFill>
+                  <a:srgbClr val="F8FAFC"/>
+                </a:solidFill>
+                <a:latin typeface="Courier New"/>
+              </a:defRPr>
+            </a:pPr>
+            <a:r>
+              <a:rPr sz="1200" b="0">
+                <a:solidFill>
+                  <a:srgbClr val="F8FAFC"/>
+                </a:solidFill>
+                <a:latin typeface="Courier New"/>
+              </a:rPr>
+              <a:t>print(f"P(≥1 falso positivo): empírico={emp:.3f}  teórico={theo:.3f}")</a:t>
+            </a:r>
+          </a:p>
+          <a:p>
+            <a:pPr>
+              <a:defRPr sz="1200" b="0">
+                <a:solidFill>
+                  <a:srgbClr val="F8FAFC"/>
+                </a:solidFill>
+                <a:latin typeface="Courier New"/>
+              </a:defRPr>
+            </a:pPr>
+            <a:r>
+              <a:rPr sz="1200" b="0">
+                <a:solidFill>
+                  <a:srgbClr val="F8FAFC"/>
+                </a:solidFill>
+                <a:latin typeface="Courier New"/>
+              </a:rPr>
+              <a:t>assert abs(emp - theo) &lt; 0.05</a:t>
             </a:r>
           </a:p>
         </p:txBody>
@@ -18025,7 +19507,7 @@
                 </a:solidFill>
                 <a:latin typeface="Segoe UI"/>
               </a:rPr>
-              <a:t>Primer bloque ejecutable del notebook.</a:t>
+              <a:t>x̄ ± t_{α/2, n-1}·(s/√n). La t tiene colas más anchas que la normal, lo que ensancha correctamente el IC con n chico.</a:t>
             </a:r>
           </a:p>
         </p:txBody>
@@ -18112,7 +19594,235 @@
                 </a:solidFill>
                 <a:latin typeface="Courier New"/>
               </a:rPr>
-              <a:t># Imports y configuración inicial</a:t>
+              <a:t>import numpy as np</a:t>
+            </a:r>
+          </a:p>
+          <a:p>
+            <a:pPr>
+              <a:defRPr sz="1200" b="0">
+                <a:solidFill>
+                  <a:srgbClr val="F8FAFC"/>
+                </a:solidFill>
+                <a:latin typeface="Courier New"/>
+              </a:defRPr>
+            </a:pPr>
+            <a:r>
+              <a:rPr sz="1200" b="0">
+                <a:solidFill>
+                  <a:srgbClr val="F8FAFC"/>
+                </a:solidFill>
+                <a:latin typeface="Courier New"/>
+              </a:rPr>
+              <a:t>from scipy import stats</a:t>
+            </a:r>
+          </a:p>
+          <a:p>
+            <a:pPr>
+              <a:defRPr sz="1200" b="0">
+                <a:solidFill>
+                  <a:srgbClr val="F8FAFC"/>
+                </a:solidFill>
+                <a:latin typeface="Courier New"/>
+              </a:defRPr>
+            </a:pPr>
+            <a:r>
+              <a:rPr sz="1200" b="0">
+                <a:solidFill>
+                  <a:srgbClr val="F8FAFC"/>
+                </a:solidFill>
+                <a:latin typeface="Courier New"/>
+              </a:rPr>
+              <a:t>from statsmodels.stats.proportion import proportion_confint</a:t>
+            </a:r>
+          </a:p>
+          <a:p>
+            <a:pPr>
+              <a:defRPr sz="1200" b="0">
+                <a:solidFill>
+                  <a:srgbClr val="F8FAFC"/>
+                </a:solidFill>
+                <a:latin typeface="Courier New"/>
+              </a:defRPr>
+            </a:pPr>
+            <a:r>
+              <a:rPr sz="1200" b="0">
+                <a:solidFill>
+                  <a:srgbClr val="F8FAFC"/>
+                </a:solidFill>
+                <a:latin typeface="Courier New"/>
+              </a:rPr>
+              <a:t>import matplotlib.pyplot as plt</a:t>
+            </a:r>
+          </a:p>
+          <a:p>
+            <a:pPr>
+              <a:defRPr sz="1200" b="0">
+                <a:solidFill>
+                  <a:srgbClr val="F8FAFC"/>
+                </a:solidFill>
+                <a:latin typeface="Courier New"/>
+              </a:defRPr>
+            </a:pPr>
+            <a:r>
+              <a:rPr sz="1200" b="0">
+                <a:solidFill>
+                  <a:srgbClr val="F8FAFC"/>
+                </a:solidFill>
+                <a:latin typeface="Courier New"/>
+              </a:rPr>
+              <a:t> </a:t>
+            </a:r>
+          </a:p>
+          <a:p>
+            <a:pPr>
+              <a:defRPr sz="1200" b="0">
+                <a:solidFill>
+                  <a:srgbClr val="F8FAFC"/>
+                </a:solidFill>
+                <a:latin typeface="Courier New"/>
+              </a:defRPr>
+            </a:pPr>
+            <a:r>
+              <a:rPr sz="1200" b="0">
+                <a:solidFill>
+                  <a:srgbClr val="F8FAFC"/>
+                </a:solidFill>
+                <a:latin typeface="Courier New"/>
+              </a:rPr>
+              <a:t>rng = np.random.default_rng(42)</a:t>
+            </a:r>
+          </a:p>
+          <a:p>
+            <a:pPr>
+              <a:defRPr sz="1200" b="0">
+                <a:solidFill>
+                  <a:srgbClr val="F8FAFC"/>
+                </a:solidFill>
+                <a:latin typeface="Courier New"/>
+              </a:defRPr>
+            </a:pPr>
+            <a:r>
+              <a:rPr sz="1200" b="0">
+                <a:solidFill>
+                  <a:srgbClr val="F8FAFC"/>
+                </a:solidFill>
+                <a:latin typeface="Courier New"/>
+              </a:rPr>
+              <a:t> </a:t>
+            </a:r>
+          </a:p>
+          <a:p>
+            <a:pPr>
+              <a:defRPr sz="1200" b="0">
+                <a:solidFill>
+                  <a:srgbClr val="F8FAFC"/>
+                </a:solidFill>
+                <a:latin typeface="Courier New"/>
+              </a:defRPr>
+            </a:pPr>
+            <a:r>
+              <a:rPr sz="1200" b="0">
+                <a:solidFill>
+                  <a:srgbClr val="F8FAFC"/>
+                </a:solidFill>
+                <a:latin typeface="Courier New"/>
+              </a:rPr>
+              <a:t>x = rng.normal(20, 8, 200)</a:t>
+            </a:r>
+          </a:p>
+          <a:p>
+            <a:pPr>
+              <a:defRPr sz="1200" b="0">
+                <a:solidFill>
+                  <a:srgbClr val="F8FAFC"/>
+                </a:solidFill>
+                <a:latin typeface="Courier New"/>
+              </a:defRPr>
+            </a:pPr>
+            <a:r>
+              <a:rPr sz="1200" b="0">
+                <a:solidFill>
+                  <a:srgbClr val="F8FAFC"/>
+                </a:solidFill>
+                <a:latin typeface="Courier New"/>
+              </a:rPr>
+              <a:t>n = len(x)</a:t>
+            </a:r>
+          </a:p>
+          <a:p>
+            <a:pPr>
+              <a:defRPr sz="1200" b="0">
+                <a:solidFill>
+                  <a:srgbClr val="F8FAFC"/>
+                </a:solidFill>
+                <a:latin typeface="Courier New"/>
+              </a:defRPr>
+            </a:pPr>
+            <a:r>
+              <a:rPr sz="1200" b="0">
+                <a:solidFill>
+                  <a:srgbClr val="F8FAFC"/>
+                </a:solidFill>
+                <a:latin typeface="Courier New"/>
+              </a:rPr>
+              <a:t>mean, sem = x.mean(), stats.sem(x)</a:t>
+            </a:r>
+          </a:p>
+          <a:p>
+            <a:pPr>
+              <a:defRPr sz="1200" b="0">
+                <a:solidFill>
+                  <a:srgbClr val="F8FAFC"/>
+                </a:solidFill>
+                <a:latin typeface="Courier New"/>
+              </a:defRPr>
+            </a:pPr>
+            <a:r>
+              <a:rPr sz="1200" b="0">
+                <a:solidFill>
+                  <a:srgbClr val="F8FAFC"/>
+                </a:solidFill>
+                <a:latin typeface="Courier New"/>
+              </a:rPr>
+              <a:t>lo, hi = stats.t.interval(0.95, n - 1, loc=mean, scale=sem)</a:t>
+            </a:r>
+          </a:p>
+          <a:p>
+            <a:pPr>
+              <a:defRPr sz="1200" b="0">
+                <a:solidFill>
+                  <a:srgbClr val="F8FAFC"/>
+                </a:solidFill>
+                <a:latin typeface="Courier New"/>
+              </a:defRPr>
+            </a:pPr>
+            <a:r>
+              <a:rPr sz="1200" b="0">
+                <a:solidFill>
+                  <a:srgbClr val="F8FAFC"/>
+                </a:solidFill>
+                <a:latin typeface="Courier New"/>
+              </a:rPr>
+              <a:t>print(f"media={mean:.2f}  IC95% t = ({lo:.2f}, {hi:.2f})")</a:t>
+            </a:r>
+          </a:p>
+          <a:p>
+            <a:pPr>
+              <a:defRPr sz="1200" b="0">
+                <a:solidFill>
+                  <a:srgbClr val="F8FAFC"/>
+                </a:solidFill>
+                <a:latin typeface="Courier New"/>
+              </a:defRPr>
+            </a:pPr>
+            <a:r>
+              <a:rPr sz="1200" b="0">
+                <a:solidFill>
+                  <a:srgbClr val="F8FAFC"/>
+                </a:solidFill>
+                <a:latin typeface="Courier New"/>
+              </a:rPr>
+              <a:t>assert lo &lt; mean &lt; hi</a:t>
             </a:r>
           </a:p>
         </p:txBody>
@@ -20059,7 +21769,7 @@
                 </a:solidFill>
                 <a:latin typeface="Segoe UI"/>
               </a:rPr>
-              <a:t>Primer bloque ejecutable del notebook.</a:t>
+              <a:t>B resamples con reemplazo del mismo tamaño; se toman los cuantiles 2.5 % y 97.5 %.</a:t>
             </a:r>
           </a:p>
         </p:txBody>
@@ -20146,7 +21856,368 @@
                 </a:solidFill>
                 <a:latin typeface="Courier New"/>
               </a:rPr>
-              <a:t># Imports y configuración inicial</a:t>
+              <a:t>import numpy as np</a:t>
+            </a:r>
+          </a:p>
+          <a:p>
+            <a:pPr>
+              <a:defRPr sz="1200" b="0">
+                <a:solidFill>
+                  <a:srgbClr val="F8FAFC"/>
+                </a:solidFill>
+                <a:latin typeface="Courier New"/>
+              </a:defRPr>
+            </a:pPr>
+            <a:r>
+              <a:rPr sz="1200" b="0">
+                <a:solidFill>
+                  <a:srgbClr val="F8FAFC"/>
+                </a:solidFill>
+                <a:latin typeface="Courier New"/>
+              </a:rPr>
+              <a:t>from scipy import stats</a:t>
+            </a:r>
+          </a:p>
+          <a:p>
+            <a:pPr>
+              <a:defRPr sz="1200" b="0">
+                <a:solidFill>
+                  <a:srgbClr val="F8FAFC"/>
+                </a:solidFill>
+                <a:latin typeface="Courier New"/>
+              </a:defRPr>
+            </a:pPr>
+            <a:r>
+              <a:rPr sz="1200" b="0">
+                <a:solidFill>
+                  <a:srgbClr val="F8FAFC"/>
+                </a:solidFill>
+                <a:latin typeface="Courier New"/>
+              </a:rPr>
+              <a:t>import matplotlib.pyplot as plt</a:t>
+            </a:r>
+          </a:p>
+          <a:p>
+            <a:pPr>
+              <a:defRPr sz="1200" b="0">
+                <a:solidFill>
+                  <a:srgbClr val="F8FAFC"/>
+                </a:solidFill>
+                <a:latin typeface="Courier New"/>
+              </a:defRPr>
+            </a:pPr>
+            <a:r>
+              <a:rPr sz="1200" b="0">
+                <a:solidFill>
+                  <a:srgbClr val="F8FAFC"/>
+                </a:solidFill>
+                <a:latin typeface="Courier New"/>
+              </a:rPr>
+              <a:t> </a:t>
+            </a:r>
+          </a:p>
+          <a:p>
+            <a:pPr>
+              <a:defRPr sz="1200" b="0">
+                <a:solidFill>
+                  <a:srgbClr val="F8FAFC"/>
+                </a:solidFill>
+                <a:latin typeface="Courier New"/>
+              </a:defRPr>
+            </a:pPr>
+            <a:r>
+              <a:rPr sz="1200" b="0">
+                <a:solidFill>
+                  <a:srgbClr val="F8FAFC"/>
+                </a:solidFill>
+                <a:latin typeface="Courier New"/>
+              </a:rPr>
+              <a:t>rng = np.random.default_rng(42)</a:t>
+            </a:r>
+          </a:p>
+          <a:p>
+            <a:pPr>
+              <a:defRPr sz="1200" b="0">
+                <a:solidFill>
+                  <a:srgbClr val="F8FAFC"/>
+                </a:solidFill>
+                <a:latin typeface="Courier New"/>
+              </a:defRPr>
+            </a:pPr>
+            <a:r>
+              <a:rPr sz="1200" b="0">
+                <a:solidFill>
+                  <a:srgbClr val="F8FAFC"/>
+                </a:solidFill>
+                <a:latin typeface="Courier New"/>
+              </a:rPr>
+              <a:t> </a:t>
+            </a:r>
+          </a:p>
+          <a:p>
+            <a:pPr>
+              <a:defRPr sz="1200" b="0">
+                <a:solidFill>
+                  <a:srgbClr val="F8FAFC"/>
+                </a:solidFill>
+                <a:latin typeface="Courier New"/>
+              </a:defRPr>
+            </a:pPr>
+            <a:r>
+              <a:rPr sz="1200" b="0">
+                <a:solidFill>
+                  <a:srgbClr val="F8FAFC"/>
+                </a:solidFill>
+                <a:latin typeface="Courier New"/>
+              </a:rPr>
+              <a:t>tip = rng.gamma(shape=2.0, scale=1.5, size=200)   # asimétrico positivo</a:t>
+            </a:r>
+          </a:p>
+          <a:p>
+            <a:pPr>
+              <a:defRPr sz="1200" b="0">
+                <a:solidFill>
+                  <a:srgbClr val="F8FAFC"/>
+                </a:solidFill>
+                <a:latin typeface="Courier New"/>
+              </a:defRPr>
+            </a:pPr>
+            <a:r>
+              <a:rPr sz="1200" b="0">
+                <a:solidFill>
+                  <a:srgbClr val="F8FAFC"/>
+                </a:solidFill>
+                <a:latin typeface="Courier New"/>
+              </a:rPr>
+              <a:t>B = 10_000</a:t>
+            </a:r>
+          </a:p>
+          <a:p>
+            <a:pPr>
+              <a:defRPr sz="1200" b="0">
+                <a:solidFill>
+                  <a:srgbClr val="F8FAFC"/>
+                </a:solidFill>
+                <a:latin typeface="Courier New"/>
+              </a:defRPr>
+            </a:pPr>
+            <a:r>
+              <a:rPr sz="1200" b="0">
+                <a:solidFill>
+                  <a:srgbClr val="F8FAFC"/>
+                </a:solidFill>
+                <a:latin typeface="Courier New"/>
+              </a:rPr>
+              <a:t>boot_means = np.array([rng.choice(tip, size=len(tip), replace=True).mean() for _ in range(B)])</a:t>
+            </a:r>
+          </a:p>
+          <a:p>
+            <a:pPr>
+              <a:defRPr sz="1200" b="0">
+                <a:solidFill>
+                  <a:srgbClr val="F8FAFC"/>
+                </a:solidFill>
+                <a:latin typeface="Courier New"/>
+              </a:defRPr>
+            </a:pPr>
+            <a:r>
+              <a:rPr sz="1200" b="0">
+                <a:solidFill>
+                  <a:srgbClr val="F8FAFC"/>
+                </a:solidFill>
+                <a:latin typeface="Courier New"/>
+              </a:rPr>
+              <a:t>lo, hi = np.percentile(boot_means, [2.5, 97.5])</a:t>
+            </a:r>
+          </a:p>
+          <a:p>
+            <a:pPr>
+              <a:defRPr sz="1200" b="0">
+                <a:solidFill>
+                  <a:srgbClr val="F8FAFC"/>
+                </a:solidFill>
+                <a:latin typeface="Courier New"/>
+              </a:defRPr>
+            </a:pPr>
+            <a:r>
+              <a:rPr sz="1200" b="0">
+                <a:solidFill>
+                  <a:srgbClr val="F8FAFC"/>
+                </a:solidFill>
+                <a:latin typeface="Courier New"/>
+              </a:rPr>
+              <a:t>sp = stats.bootstrap((tip,), np.mean, n_resamples=B, method="percentile", random_state=rng)</a:t>
+            </a:r>
+          </a:p>
+          <a:p>
+            <a:pPr>
+              <a:defRPr sz="1200" b="0">
+                <a:solidFill>
+                  <a:srgbClr val="F8FAFC"/>
+                </a:solidFill>
+                <a:latin typeface="Courier New"/>
+              </a:defRPr>
+            </a:pPr>
+            <a:r>
+              <a:rPr sz="1200" b="0">
+                <a:solidFill>
+                  <a:srgbClr val="F8FAFC"/>
+                </a:solidFill>
+                <a:latin typeface="Courier New"/>
+              </a:rPr>
+              <a:t>print(f"manual  IC95% = ({lo:.3f}, {hi:.3f})")</a:t>
+            </a:r>
+          </a:p>
+          <a:p>
+            <a:pPr>
+              <a:defRPr sz="1200" b="0">
+                <a:solidFill>
+                  <a:srgbClr val="F8FAFC"/>
+                </a:solidFill>
+                <a:latin typeface="Courier New"/>
+              </a:defRPr>
+            </a:pPr>
+            <a:r>
+              <a:rPr sz="1200" b="0">
+                <a:solidFill>
+                  <a:srgbClr val="F8FAFC"/>
+                </a:solidFill>
+                <a:latin typeface="Courier New"/>
+              </a:rPr>
+              <a:t>print(f"scipy   IC95% = ({sp.confidence_interval.low:.3f}, {sp.confidence_interval.high:.3f})")</a:t>
+            </a:r>
+          </a:p>
+          <a:p>
+            <a:pPr>
+              <a:defRPr sz="1200" b="0">
+                <a:solidFill>
+                  <a:srgbClr val="F8FAFC"/>
+                </a:solidFill>
+                <a:latin typeface="Courier New"/>
+              </a:defRPr>
+            </a:pPr>
+            <a:r>
+              <a:rPr sz="1200" b="0">
+                <a:solidFill>
+                  <a:srgbClr val="F8FAFC"/>
+                </a:solidFill>
+                <a:latin typeface="Courier New"/>
+              </a:rPr>
+              <a:t>assert abs(lo - sp.confidence_interval.low) &lt; 0.1</a:t>
+            </a:r>
+          </a:p>
+          <a:p>
+            <a:pPr>
+              <a:defRPr sz="1200" b="0">
+                <a:solidFill>
+                  <a:srgbClr val="F8FAFC"/>
+                </a:solidFill>
+                <a:latin typeface="Courier New"/>
+              </a:defRPr>
+            </a:pPr>
+            <a:r>
+              <a:rPr sz="1200" b="0">
+                <a:solidFill>
+                  <a:srgbClr val="F8FAFC"/>
+                </a:solidFill>
+                <a:latin typeface="Courier New"/>
+              </a:rPr>
+              <a:t> </a:t>
+            </a:r>
+          </a:p>
+          <a:p>
+            <a:pPr>
+              <a:defRPr sz="1200" b="0">
+                <a:solidFill>
+                  <a:srgbClr val="F8FAFC"/>
+                </a:solidFill>
+                <a:latin typeface="Courier New"/>
+              </a:defRPr>
+            </a:pPr>
+            <a:r>
+              <a:rPr sz="1200" b="0">
+                <a:solidFill>
+                  <a:srgbClr val="F8FAFC"/>
+                </a:solidFill>
+                <a:latin typeface="Courier New"/>
+              </a:rPr>
+              <a:t>plt.figure(figsize=(6, 4))</a:t>
+            </a:r>
+          </a:p>
+          <a:p>
+            <a:pPr>
+              <a:defRPr sz="1200" b="0">
+                <a:solidFill>
+                  <a:srgbClr val="F8FAFC"/>
+                </a:solidFill>
+                <a:latin typeface="Courier New"/>
+              </a:defRPr>
+            </a:pPr>
+            <a:r>
+              <a:rPr sz="1200" b="0">
+                <a:solidFill>
+                  <a:srgbClr val="F8FAFC"/>
+                </a:solidFill>
+                <a:latin typeface="Courier New"/>
+              </a:rPr>
+              <a:t>plt.hist(boot_means, bins=50, color="darkorange", alpha=0.7)</a:t>
+            </a:r>
+          </a:p>
+          <a:p>
+            <a:pPr>
+              <a:defRPr sz="1200" b="0">
+                <a:solidFill>
+                  <a:srgbClr val="F8FAFC"/>
+                </a:solidFill>
+                <a:latin typeface="Courier New"/>
+              </a:defRPr>
+            </a:pPr>
+            <a:r>
+              <a:rPr sz="1200" b="0">
+                <a:solidFill>
+                  <a:srgbClr val="F8FAFC"/>
+                </a:solidFill>
+                <a:latin typeface="Courier New"/>
+              </a:rPr>
+              <a:t>plt.axvline(lo, color="k", ls="--"); plt.axvline(hi, color="k", ls="--")</a:t>
+            </a:r>
+          </a:p>
+          <a:p>
+            <a:pPr>
+              <a:defRPr sz="1200" b="0">
+                <a:solidFill>
+                  <a:srgbClr val="F8FAFC"/>
+                </a:solidFill>
+                <a:latin typeface="Courier New"/>
+              </a:defRPr>
+            </a:pPr>
+            <a:r>
+              <a:rPr sz="1200" b="0">
+                <a:solidFill>
+                  <a:srgbClr val="F8FAFC"/>
+                </a:solidFill>
+                <a:latin typeface="Courier New"/>
+              </a:rPr>
+              <a:t>plt.title("Distribución bootstrap de la media (IC95% percentil)")</a:t>
+            </a:r>
+          </a:p>
+          <a:p>
+            <a:pPr>
+              <a:defRPr sz="1200" b="0">
+                <a:solidFill>
+                  <a:srgbClr val="F8FAFC"/>
+                </a:solidFill>
+                <a:latin typeface="Courier New"/>
+              </a:defRPr>
+            </a:pPr>
+            <a:r>
+              <a:rPr sz="1200" b="0">
+                <a:solidFill>
+                  <a:srgbClr val="F8FAFC"/>
+                </a:solidFill>
+                <a:latin typeface="Courier New"/>
+              </a:rPr>
+              <a:t>plt.tight_layout(); plt.show()</a:t>
             </a:r>
           </a:p>
         </p:txBody>
@@ -24812,7 +26883,7 @@
                 </a:solidFill>
                 <a:latin typeface="Segoe UI"/>
               </a:rPr>
-              <a:t>Primer bloque ejecutable del notebook.</a:t>
+              <a:t>n depende de α, poder (1-β) y del effect size. Para proporciones usamos Cohen's h y NormalIndPower.</a:t>
             </a:r>
           </a:p>
         </p:txBody>
@@ -24899,7 +26970,254 @@
                 </a:solidFill>
                 <a:latin typeface="Courier New"/>
               </a:rPr>
-              <a:t># Imports y configuración inicial</a:t>
+              <a:t>import numpy as np</a:t>
+            </a:r>
+          </a:p>
+          <a:p>
+            <a:pPr>
+              <a:defRPr sz="1200" b="0">
+                <a:solidFill>
+                  <a:srgbClr val="F8FAFC"/>
+                </a:solidFill>
+                <a:latin typeface="Courier New"/>
+              </a:defRPr>
+            </a:pPr>
+            <a:r>
+              <a:rPr sz="1200" b="0">
+                <a:solidFill>
+                  <a:srgbClr val="F8FAFC"/>
+                </a:solidFill>
+                <a:latin typeface="Courier New"/>
+              </a:rPr>
+              <a:t>from scipy import stats</a:t>
+            </a:r>
+          </a:p>
+          <a:p>
+            <a:pPr>
+              <a:defRPr sz="1200" b="0">
+                <a:solidFill>
+                  <a:srgbClr val="F8FAFC"/>
+                </a:solidFill>
+                <a:latin typeface="Courier New"/>
+              </a:defRPr>
+            </a:pPr>
+            <a:r>
+              <a:rPr sz="1200" b="0">
+                <a:solidFill>
+                  <a:srgbClr val="F8FAFC"/>
+                </a:solidFill>
+                <a:latin typeface="Courier New"/>
+              </a:rPr>
+              <a:t>from statsmodels.stats.power import NormalIndPower</a:t>
+            </a:r>
+          </a:p>
+          <a:p>
+            <a:pPr>
+              <a:defRPr sz="1200" b="0">
+                <a:solidFill>
+                  <a:srgbClr val="F8FAFC"/>
+                </a:solidFill>
+                <a:latin typeface="Courier New"/>
+              </a:defRPr>
+            </a:pPr>
+            <a:r>
+              <a:rPr sz="1200" b="0">
+                <a:solidFill>
+                  <a:srgbClr val="F8FAFC"/>
+                </a:solidFill>
+                <a:latin typeface="Courier New"/>
+              </a:rPr>
+              <a:t>from statsmodels.stats.proportion import proportion_effectsize, proportions_ztest, confint_proportions_2indep</a:t>
+            </a:r>
+          </a:p>
+          <a:p>
+            <a:pPr>
+              <a:defRPr sz="1200" b="0">
+                <a:solidFill>
+                  <a:srgbClr val="F8FAFC"/>
+                </a:solidFill>
+                <a:latin typeface="Courier New"/>
+              </a:defRPr>
+            </a:pPr>
+            <a:r>
+              <a:rPr sz="1200" b="0">
+                <a:solidFill>
+                  <a:srgbClr val="F8FAFC"/>
+                </a:solidFill>
+                <a:latin typeface="Courier New"/>
+              </a:rPr>
+              <a:t>import matplotlib.pyplot as plt</a:t>
+            </a:r>
+          </a:p>
+          <a:p>
+            <a:pPr>
+              <a:defRPr sz="1200" b="0">
+                <a:solidFill>
+                  <a:srgbClr val="F8FAFC"/>
+                </a:solidFill>
+                <a:latin typeface="Courier New"/>
+              </a:defRPr>
+            </a:pPr>
+            <a:r>
+              <a:rPr sz="1200" b="0">
+                <a:solidFill>
+                  <a:srgbClr val="F8FAFC"/>
+                </a:solidFill>
+                <a:latin typeface="Courier New"/>
+              </a:rPr>
+              <a:t> </a:t>
+            </a:r>
+          </a:p>
+          <a:p>
+            <a:pPr>
+              <a:defRPr sz="1200" b="0">
+                <a:solidFill>
+                  <a:srgbClr val="F8FAFC"/>
+                </a:solidFill>
+                <a:latin typeface="Courier New"/>
+              </a:defRPr>
+            </a:pPr>
+            <a:r>
+              <a:rPr sz="1200" b="0">
+                <a:solidFill>
+                  <a:srgbClr val="F8FAFC"/>
+                </a:solidFill>
+                <a:latin typeface="Courier New"/>
+              </a:rPr>
+              <a:t>rng = np.random.default_rng(42)</a:t>
+            </a:r>
+          </a:p>
+          <a:p>
+            <a:pPr>
+              <a:defRPr sz="1200" b="0">
+                <a:solidFill>
+                  <a:srgbClr val="F8FAFC"/>
+                </a:solidFill>
+                <a:latin typeface="Courier New"/>
+              </a:defRPr>
+            </a:pPr>
+            <a:r>
+              <a:rPr sz="1200" b="0">
+                <a:solidFill>
+                  <a:srgbClr val="F8FAFC"/>
+                </a:solidFill>
+                <a:latin typeface="Courier New"/>
+              </a:rPr>
+              <a:t> </a:t>
+            </a:r>
+          </a:p>
+          <a:p>
+            <a:pPr>
+              <a:defRPr sz="1200" b="0">
+                <a:solidFill>
+                  <a:srgbClr val="F8FAFC"/>
+                </a:solidFill>
+                <a:latin typeface="Courier New"/>
+              </a:defRPr>
+            </a:pPr>
+            <a:r>
+              <a:rPr sz="1200" b="0">
+                <a:solidFill>
+                  <a:srgbClr val="F8FAFC"/>
+                </a:solidFill>
+                <a:latin typeface="Courier New"/>
+              </a:rPr>
+              <a:t>p0, p1 = 0.10, 0.11</a:t>
+            </a:r>
+          </a:p>
+          <a:p>
+            <a:pPr>
+              <a:defRPr sz="1200" b="0">
+                <a:solidFill>
+                  <a:srgbClr val="F8FAFC"/>
+                </a:solidFill>
+                <a:latin typeface="Courier New"/>
+              </a:defRPr>
+            </a:pPr>
+            <a:r>
+              <a:rPr sz="1200" b="0">
+                <a:solidFill>
+                  <a:srgbClr val="F8FAFC"/>
+                </a:solidFill>
+                <a:latin typeface="Courier New"/>
+              </a:rPr>
+              <a:t>h = proportion_effectsize(p1, p0)   # Cohen's h</a:t>
+            </a:r>
+          </a:p>
+          <a:p>
+            <a:pPr>
+              <a:defRPr sz="1200" b="0">
+                <a:solidFill>
+                  <a:srgbClr val="F8FAFC"/>
+                </a:solidFill>
+                <a:latin typeface="Courier New"/>
+              </a:defRPr>
+            </a:pPr>
+            <a:r>
+              <a:rPr sz="1200" b="0">
+                <a:solidFill>
+                  <a:srgbClr val="F8FAFC"/>
+                </a:solidFill>
+                <a:latin typeface="Courier New"/>
+              </a:rPr>
+              <a:t>n_req = NormalIndPower().solve_power(effect_size=h, alpha=0.05, power=0.8, alternative="two-sided")</a:t>
+            </a:r>
+          </a:p>
+          <a:p>
+            <a:pPr>
+              <a:defRPr sz="1200" b="0">
+                <a:solidFill>
+                  <a:srgbClr val="F8FAFC"/>
+                </a:solidFill>
+                <a:latin typeface="Courier New"/>
+              </a:defRPr>
+            </a:pPr>
+            <a:r>
+              <a:rPr sz="1200" b="0">
+                <a:solidFill>
+                  <a:srgbClr val="F8FAFC"/>
+                </a:solidFill>
+                <a:latin typeface="Courier New"/>
+              </a:rPr>
+              <a:t>print(f"Cohen's h = {h:.4f}")</a:t>
+            </a:r>
+          </a:p>
+          <a:p>
+            <a:pPr>
+              <a:defRPr sz="1200" b="0">
+                <a:solidFill>
+                  <a:srgbClr val="F8FAFC"/>
+                </a:solidFill>
+                <a:latin typeface="Courier New"/>
+              </a:defRPr>
+            </a:pPr>
+            <a:r>
+              <a:rPr sz="1200" b="0">
+                <a:solidFill>
+                  <a:srgbClr val="F8FAFC"/>
+                </a:solidFill>
+                <a:latin typeface="Courier New"/>
+              </a:rPr>
+              <a:t>print(f"n por grupo para detectar 10%→11% (poder 0.8, α=0.05) = {np.ceil(n_req):.0f}")</a:t>
+            </a:r>
+          </a:p>
+          <a:p>
+            <a:pPr>
+              <a:defRPr sz="1200" b="0">
+                <a:solidFill>
+                  <a:srgbClr val="F8FAFC"/>
+                </a:solidFill>
+                <a:latin typeface="Courier New"/>
+              </a:defRPr>
+            </a:pPr>
+            <a:r>
+              <a:rPr sz="1200" b="0">
+                <a:solidFill>
+                  <a:srgbClr val="F8FAFC"/>
+                </a:solidFill>
+                <a:latin typeface="Courier New"/>
+              </a:rPr>
+              <a:t>assert n_req &gt; 5000</a:t>
             </a:r>
           </a:p>
         </p:txBody>
@@ -29489,7 +31807,7 @@
                 </a:solidFill>
                 <a:latin typeface="Segoe UI"/>
               </a:rPr>
-              <a:t>Primer bloque ejecutable del notebook.</a:t>
+              <a:t>Testeamos dos factores a la vez y recuperamos efectos principales + interacción con un OLS y ~ A*B.</a:t>
             </a:r>
           </a:p>
         </p:txBody>
@@ -29576,7 +31894,387 @@
                 </a:solidFill>
                 <a:latin typeface="Courier New"/>
               </a:rPr>
-              <a:t># Imports y configuración inicial</a:t>
+              <a:t>import itertools</a:t>
+            </a:r>
+          </a:p>
+          <a:p>
+            <a:pPr>
+              <a:defRPr sz="1200" b="0">
+                <a:solidFill>
+                  <a:srgbClr val="F8FAFC"/>
+                </a:solidFill>
+                <a:latin typeface="Courier New"/>
+              </a:defRPr>
+            </a:pPr>
+            <a:r>
+              <a:rPr sz="1200" b="0">
+                <a:solidFill>
+                  <a:srgbClr val="F8FAFC"/>
+                </a:solidFill>
+                <a:latin typeface="Courier New"/>
+              </a:rPr>
+              <a:t>import numpy as np</a:t>
+            </a:r>
+          </a:p>
+          <a:p>
+            <a:pPr>
+              <a:defRPr sz="1200" b="0">
+                <a:solidFill>
+                  <a:srgbClr val="F8FAFC"/>
+                </a:solidFill>
+                <a:latin typeface="Courier New"/>
+              </a:defRPr>
+            </a:pPr>
+            <a:r>
+              <a:rPr sz="1200" b="0">
+                <a:solidFill>
+                  <a:srgbClr val="F8FAFC"/>
+                </a:solidFill>
+                <a:latin typeface="Courier New"/>
+              </a:rPr>
+              <a:t>import pandas as pd</a:t>
+            </a:r>
+          </a:p>
+          <a:p>
+            <a:pPr>
+              <a:defRPr sz="1200" b="0">
+                <a:solidFill>
+                  <a:srgbClr val="F8FAFC"/>
+                </a:solidFill>
+                <a:latin typeface="Courier New"/>
+              </a:defRPr>
+            </a:pPr>
+            <a:r>
+              <a:rPr sz="1200" b="0">
+                <a:solidFill>
+                  <a:srgbClr val="F8FAFC"/>
+                </a:solidFill>
+                <a:latin typeface="Courier New"/>
+              </a:rPr>
+              <a:t>from scipy import stats</a:t>
+            </a:r>
+          </a:p>
+          <a:p>
+            <a:pPr>
+              <a:defRPr sz="1200" b="0">
+                <a:solidFill>
+                  <a:srgbClr val="F8FAFC"/>
+                </a:solidFill>
+                <a:latin typeface="Courier New"/>
+              </a:defRPr>
+            </a:pPr>
+            <a:r>
+              <a:rPr sz="1200" b="0">
+                <a:solidFill>
+                  <a:srgbClr val="F8FAFC"/>
+                </a:solidFill>
+                <a:latin typeface="Courier New"/>
+              </a:rPr>
+              <a:t>import statsmodels.formula.api as smf</a:t>
+            </a:r>
+          </a:p>
+          <a:p>
+            <a:pPr>
+              <a:defRPr sz="1200" b="0">
+                <a:solidFill>
+                  <a:srgbClr val="F8FAFC"/>
+                </a:solidFill>
+                <a:latin typeface="Courier New"/>
+              </a:defRPr>
+            </a:pPr>
+            <a:r>
+              <a:rPr sz="1200" b="0">
+                <a:solidFill>
+                  <a:srgbClr val="F8FAFC"/>
+                </a:solidFill>
+                <a:latin typeface="Courier New"/>
+              </a:rPr>
+              <a:t>import matplotlib.pyplot as plt</a:t>
+            </a:r>
+          </a:p>
+          <a:p>
+            <a:pPr>
+              <a:defRPr sz="1200" b="0">
+                <a:solidFill>
+                  <a:srgbClr val="F8FAFC"/>
+                </a:solidFill>
+                <a:latin typeface="Courier New"/>
+              </a:defRPr>
+            </a:pPr>
+            <a:r>
+              <a:rPr sz="1200" b="0">
+                <a:solidFill>
+                  <a:srgbClr val="F8FAFC"/>
+                </a:solidFill>
+                <a:latin typeface="Courier New"/>
+              </a:rPr>
+              <a:t> </a:t>
+            </a:r>
+          </a:p>
+          <a:p>
+            <a:pPr>
+              <a:defRPr sz="1200" b="0">
+                <a:solidFill>
+                  <a:srgbClr val="F8FAFC"/>
+                </a:solidFill>
+                <a:latin typeface="Courier New"/>
+              </a:defRPr>
+            </a:pPr>
+            <a:r>
+              <a:rPr sz="1200" b="0">
+                <a:solidFill>
+                  <a:srgbClr val="F8FAFC"/>
+                </a:solidFill>
+                <a:latin typeface="Courier New"/>
+              </a:rPr>
+              <a:t>rng = np.random.default_rng(42)</a:t>
+            </a:r>
+          </a:p>
+          <a:p>
+            <a:pPr>
+              <a:defRPr sz="1200" b="0">
+                <a:solidFill>
+                  <a:srgbClr val="F8FAFC"/>
+                </a:solidFill>
+                <a:latin typeface="Courier New"/>
+              </a:defRPr>
+            </a:pPr>
+            <a:r>
+              <a:rPr sz="1200" b="0">
+                <a:solidFill>
+                  <a:srgbClr val="F8FAFC"/>
+                </a:solidFill>
+                <a:latin typeface="Courier New"/>
+              </a:rPr>
+              <a:t> </a:t>
+            </a:r>
+          </a:p>
+          <a:p>
+            <a:pPr>
+              <a:defRPr sz="1200" b="0">
+                <a:solidFill>
+                  <a:srgbClr val="F8FAFC"/>
+                </a:solidFill>
+                <a:latin typeface="Courier New"/>
+              </a:defRPr>
+            </a:pPr>
+            <a:r>
+              <a:rPr sz="1200" b="0">
+                <a:solidFill>
+                  <a:srgbClr val="F8FAFC"/>
+                </a:solidFill>
+                <a:latin typeface="Courier New"/>
+              </a:rPr>
+              <a:t>nper = 1000</a:t>
+            </a:r>
+          </a:p>
+          <a:p>
+            <a:pPr>
+              <a:defRPr sz="1200" b="0">
+                <a:solidFill>
+                  <a:srgbClr val="F8FAFC"/>
+                </a:solidFill>
+                <a:latin typeface="Courier New"/>
+              </a:defRPr>
+            </a:pPr>
+            <a:r>
+              <a:rPr sz="1200" b="0">
+                <a:solidFill>
+                  <a:srgbClr val="F8FAFC"/>
+                </a:solidFill>
+                <a:latin typeface="Courier New"/>
+              </a:rPr>
+              <a:t>rows = []</a:t>
+            </a:r>
+          </a:p>
+          <a:p>
+            <a:pPr>
+              <a:defRPr sz="1200" b="0">
+                <a:solidFill>
+                  <a:srgbClr val="F8FAFC"/>
+                </a:solidFill>
+                <a:latin typeface="Courier New"/>
+              </a:defRPr>
+            </a:pPr>
+            <a:r>
+              <a:rPr sz="1200" b="0">
+                <a:solidFill>
+                  <a:srgbClr val="F8FAFC"/>
+                </a:solidFill>
+                <a:latin typeface="Courier New"/>
+              </a:rPr>
+              <a:t>for A in (0, 1):</a:t>
+            </a:r>
+          </a:p>
+          <a:p>
+            <a:pPr>
+              <a:defRPr sz="1200" b="0">
+                <a:solidFill>
+                  <a:srgbClr val="F8FAFC"/>
+                </a:solidFill>
+                <a:latin typeface="Courier New"/>
+              </a:defRPr>
+            </a:pPr>
+            <a:r>
+              <a:rPr sz="1200" b="0">
+                <a:solidFill>
+                  <a:srgbClr val="F8FAFC"/>
+                </a:solidFill>
+                <a:latin typeface="Courier New"/>
+              </a:rPr>
+              <a:t>    for Bf in (0, 1):</a:t>
+            </a:r>
+          </a:p>
+          <a:p>
+            <a:pPr>
+              <a:defRPr sz="1200" b="0">
+                <a:solidFill>
+                  <a:srgbClr val="F8FAFC"/>
+                </a:solidFill>
+                <a:latin typeface="Courier New"/>
+              </a:defRPr>
+            </a:pPr>
+            <a:r>
+              <a:rPr sz="1200" b="0">
+                <a:solidFill>
+                  <a:srgbClr val="F8FAFC"/>
+                </a:solidFill>
+                <a:latin typeface="Courier New"/>
+              </a:rPr>
+              <a:t>        ctr = 0.10 + 0.02*A + 0.015*Bf + 0.02*A*Bf + rng.normal(0, 0.05, nper)</a:t>
+            </a:r>
+          </a:p>
+          <a:p>
+            <a:pPr>
+              <a:defRPr sz="1200" b="0">
+                <a:solidFill>
+                  <a:srgbClr val="F8FAFC"/>
+                </a:solidFill>
+                <a:latin typeface="Courier New"/>
+              </a:defRPr>
+            </a:pPr>
+            <a:r>
+              <a:rPr sz="1200" b="0">
+                <a:solidFill>
+                  <a:srgbClr val="F8FAFC"/>
+                </a:solidFill>
+                <a:latin typeface="Courier New"/>
+              </a:rPr>
+              <a:t>        for v in ctr:</a:t>
+            </a:r>
+          </a:p>
+          <a:p>
+            <a:pPr>
+              <a:defRPr sz="1200" b="0">
+                <a:solidFill>
+                  <a:srgbClr val="F8FAFC"/>
+                </a:solidFill>
+                <a:latin typeface="Courier New"/>
+              </a:defRPr>
+            </a:pPr>
+            <a:r>
+              <a:rPr sz="1200" b="0">
+                <a:solidFill>
+                  <a:srgbClr val="F8FAFC"/>
+                </a:solidFill>
+                <a:latin typeface="Courier New"/>
+              </a:rPr>
+              <a:t>            rows.append((A, Bf, v))</a:t>
+            </a:r>
+          </a:p>
+          <a:p>
+            <a:pPr>
+              <a:defRPr sz="1200" b="0">
+                <a:solidFill>
+                  <a:srgbClr val="F8FAFC"/>
+                </a:solidFill>
+                <a:latin typeface="Courier New"/>
+              </a:defRPr>
+            </a:pPr>
+            <a:r>
+              <a:rPr sz="1200" b="0">
+                <a:solidFill>
+                  <a:srgbClr val="F8FAFC"/>
+                </a:solidFill>
+                <a:latin typeface="Courier New"/>
+              </a:rPr>
+              <a:t>df = pd.DataFrame(rows, columns=["A", "B", "ctr"])</a:t>
+            </a:r>
+          </a:p>
+          <a:p>
+            <a:pPr>
+              <a:defRPr sz="1200" b="0">
+                <a:solidFill>
+                  <a:srgbClr val="F8FAFC"/>
+                </a:solidFill>
+                <a:latin typeface="Courier New"/>
+              </a:defRPr>
+            </a:pPr>
+            <a:r>
+              <a:rPr sz="1200" b="0">
+                <a:solidFill>
+                  <a:srgbClr val="F8FAFC"/>
+                </a:solidFill>
+                <a:latin typeface="Courier New"/>
+              </a:rPr>
+              <a:t>m = smf.ols("ctr ~ A * B", data=df).fit()</a:t>
+            </a:r>
+          </a:p>
+          <a:p>
+            <a:pPr>
+              <a:defRPr sz="1200" b="0">
+                <a:solidFill>
+                  <a:srgbClr val="F8FAFC"/>
+                </a:solidFill>
+                <a:latin typeface="Courier New"/>
+              </a:defRPr>
+            </a:pPr>
+            <a:r>
+              <a:rPr sz="1200" b="0">
+                <a:solidFill>
+                  <a:srgbClr val="F8FAFC"/>
+                </a:solidFill>
+                <a:latin typeface="Courier New"/>
+              </a:rPr>
+              <a:t>print(m.params.round(4))</a:t>
+            </a:r>
+          </a:p>
+          <a:p>
+            <a:pPr>
+              <a:defRPr sz="1200" b="0">
+                <a:solidFill>
+                  <a:srgbClr val="F8FAFC"/>
+                </a:solidFill>
+                <a:latin typeface="Courier New"/>
+              </a:defRPr>
+            </a:pPr>
+            <a:r>
+              <a:rPr sz="1200" b="0">
+                <a:solidFill>
+                  <a:srgbClr val="F8FAFC"/>
+                </a:solidFill>
+                <a:latin typeface="Courier New"/>
+              </a:rPr>
+              <a:t>print("\nverdaderos: Intercept=0.10, A=0.02, B=0.015, A:B=0.02")</a:t>
+            </a:r>
+          </a:p>
+          <a:p>
+            <a:pPr>
+              <a:defRPr sz="1200" b="0">
+                <a:solidFill>
+                  <a:srgbClr val="F8FAFC"/>
+                </a:solidFill>
+                <a:latin typeface="Courier New"/>
+              </a:defRPr>
+            </a:pPr>
+            <a:r>
+              <a:rPr sz="1200" b="0">
+                <a:solidFill>
+                  <a:srgbClr val="F8FAFC"/>
+                </a:solidFill>
+                <a:latin typeface="Courier New"/>
+              </a:rPr>
+              <a:t># ... (truncado)</a:t>
             </a:r>
           </a:p>
         </p:txBody>
@@ -30571,7 +33269,7 @@
                 </a:solidFill>
                 <a:latin typeface="Segoe UI"/>
               </a:rPr>
-              <a:t>Primer bloque ejecutable del notebook.</a:t>
+              <a:t>Simétrica, soporte en toda la recta. Base de t-test, ANOVA e intervalos de confianza. Verificamos la regla 68-95-99.7.</a:t>
             </a:r>
           </a:p>
         </p:txBody>
@@ -30658,7 +33356,387 @@
                 </a:solidFill>
                 <a:latin typeface="Courier New"/>
               </a:rPr>
-              <a:t># Imports y configuración inicial</a:t>
+              <a:t>import numpy as np</a:t>
+            </a:r>
+          </a:p>
+          <a:p>
+            <a:pPr>
+              <a:defRPr sz="1200" b="0">
+                <a:solidFill>
+                  <a:srgbClr val="F8FAFC"/>
+                </a:solidFill>
+                <a:latin typeface="Courier New"/>
+              </a:defRPr>
+            </a:pPr>
+            <a:r>
+              <a:rPr sz="1200" b="0">
+                <a:solidFill>
+                  <a:srgbClr val="F8FAFC"/>
+                </a:solidFill>
+                <a:latin typeface="Courier New"/>
+              </a:rPr>
+              <a:t>from scipy import stats</a:t>
+            </a:r>
+          </a:p>
+          <a:p>
+            <a:pPr>
+              <a:defRPr sz="1200" b="0">
+                <a:solidFill>
+                  <a:srgbClr val="F8FAFC"/>
+                </a:solidFill>
+                <a:latin typeface="Courier New"/>
+              </a:defRPr>
+            </a:pPr>
+            <a:r>
+              <a:rPr sz="1200" b="0">
+                <a:solidFill>
+                  <a:srgbClr val="F8FAFC"/>
+                </a:solidFill>
+                <a:latin typeface="Courier New"/>
+              </a:rPr>
+              <a:t>import matplotlib.pyplot as plt</a:t>
+            </a:r>
+          </a:p>
+          <a:p>
+            <a:pPr>
+              <a:defRPr sz="1200" b="0">
+                <a:solidFill>
+                  <a:srgbClr val="F8FAFC"/>
+                </a:solidFill>
+                <a:latin typeface="Courier New"/>
+              </a:defRPr>
+            </a:pPr>
+            <a:r>
+              <a:rPr sz="1200" b="0">
+                <a:solidFill>
+                  <a:srgbClr val="F8FAFC"/>
+                </a:solidFill>
+                <a:latin typeface="Courier New"/>
+              </a:rPr>
+              <a:t> </a:t>
+            </a:r>
+          </a:p>
+          <a:p>
+            <a:pPr>
+              <a:defRPr sz="1200" b="0">
+                <a:solidFill>
+                  <a:srgbClr val="F8FAFC"/>
+                </a:solidFill>
+                <a:latin typeface="Courier New"/>
+              </a:defRPr>
+            </a:pPr>
+            <a:r>
+              <a:rPr sz="1200" b="0">
+                <a:solidFill>
+                  <a:srgbClr val="F8FAFC"/>
+                </a:solidFill>
+                <a:latin typeface="Courier New"/>
+              </a:rPr>
+              <a:t>rng = np.random.default_rng(42)</a:t>
+            </a:r>
+          </a:p>
+          <a:p>
+            <a:pPr>
+              <a:defRPr sz="1200" b="0">
+                <a:solidFill>
+                  <a:srgbClr val="F8FAFC"/>
+                </a:solidFill>
+                <a:latin typeface="Courier New"/>
+              </a:defRPr>
+            </a:pPr>
+            <a:r>
+              <a:rPr sz="1200" b="0">
+                <a:solidFill>
+                  <a:srgbClr val="F8FAFC"/>
+                </a:solidFill>
+                <a:latin typeface="Courier New"/>
+              </a:rPr>
+              <a:t>np.random.seed(42)</a:t>
+            </a:r>
+          </a:p>
+          <a:p>
+            <a:pPr>
+              <a:defRPr sz="1200" b="0">
+                <a:solidFill>
+                  <a:srgbClr val="F8FAFC"/>
+                </a:solidFill>
+                <a:latin typeface="Courier New"/>
+              </a:defRPr>
+            </a:pPr>
+            <a:r>
+              <a:rPr sz="1200" b="0">
+                <a:solidFill>
+                  <a:srgbClr val="F8FAFC"/>
+                </a:solidFill>
+                <a:latin typeface="Courier New"/>
+              </a:rPr>
+              <a:t> </a:t>
+            </a:r>
+          </a:p>
+          <a:p>
+            <a:pPr>
+              <a:defRPr sz="1200" b="0">
+                <a:solidFill>
+                  <a:srgbClr val="F8FAFC"/>
+                </a:solidFill>
+                <a:latin typeface="Courier New"/>
+              </a:defRPr>
+            </a:pPr>
+            <a:r>
+              <a:rPr sz="1200" b="0">
+                <a:solidFill>
+                  <a:srgbClr val="F8FAFC"/>
+                </a:solidFill>
+                <a:latin typeface="Courier New"/>
+              </a:rPr>
+              <a:t>mu, sigma = 100.0, 15.0</a:t>
+            </a:r>
+          </a:p>
+          <a:p>
+            <a:pPr>
+              <a:defRPr sz="1200" b="0">
+                <a:solidFill>
+                  <a:srgbClr val="F8FAFC"/>
+                </a:solidFill>
+                <a:latin typeface="Courier New"/>
+              </a:defRPr>
+            </a:pPr>
+            <a:r>
+              <a:rPr sz="1200" b="0">
+                <a:solidFill>
+                  <a:srgbClr val="F8FAFC"/>
+                </a:solidFill>
+                <a:latin typeface="Courier New"/>
+              </a:rPr>
+              <a:t>x = rng.normal(mu, sigma, 10_000)</a:t>
+            </a:r>
+          </a:p>
+          <a:p>
+            <a:pPr>
+              <a:defRPr sz="1200" b="0">
+                <a:solidFill>
+                  <a:srgbClr val="F8FAFC"/>
+                </a:solidFill>
+                <a:latin typeface="Courier New"/>
+              </a:defRPr>
+            </a:pPr>
+            <a:r>
+              <a:rPr sz="1200" b="0">
+                <a:solidFill>
+                  <a:srgbClr val="F8FAFC"/>
+                </a:solidFill>
+                <a:latin typeface="Courier New"/>
+              </a:rPr>
+              <a:t>print(f"Normal N(100, 15^2): media={x.mean():.2f}  sd={x.std(ddof=1):.2f}")</a:t>
+            </a:r>
+          </a:p>
+          <a:p>
+            <a:pPr>
+              <a:defRPr sz="1200" b="0">
+                <a:solidFill>
+                  <a:srgbClr val="F8FAFC"/>
+                </a:solidFill>
+                <a:latin typeface="Courier New"/>
+              </a:defRPr>
+            </a:pPr>
+            <a:r>
+              <a:rPr sz="1200" b="0">
+                <a:solidFill>
+                  <a:srgbClr val="F8FAFC"/>
+                </a:solidFill>
+                <a:latin typeface="Courier New"/>
+              </a:rPr>
+              <a:t> </a:t>
+            </a:r>
+          </a:p>
+          <a:p>
+            <a:pPr>
+              <a:defRPr sz="1200" b="0">
+                <a:solidFill>
+                  <a:srgbClr val="F8FAFC"/>
+                </a:solidFill>
+                <a:latin typeface="Courier New"/>
+              </a:defRPr>
+            </a:pPr>
+            <a:r>
+              <a:rPr sz="1200" b="0">
+                <a:solidFill>
+                  <a:srgbClr val="F8FAFC"/>
+                </a:solidFill>
+                <a:latin typeface="Courier New"/>
+              </a:rPr>
+              <a:t>for k in (1, 2, 3):</a:t>
+            </a:r>
+          </a:p>
+          <a:p>
+            <a:pPr>
+              <a:defRPr sz="1200" b="0">
+                <a:solidFill>
+                  <a:srgbClr val="F8FAFC"/>
+                </a:solidFill>
+                <a:latin typeface="Courier New"/>
+              </a:defRPr>
+            </a:pPr>
+            <a:r>
+              <a:rPr sz="1200" b="0">
+                <a:solidFill>
+                  <a:srgbClr val="F8FAFC"/>
+                </a:solidFill>
+                <a:latin typeface="Courier New"/>
+              </a:rPr>
+              <a:t>    frac = np.mean(np.abs(x - mu) &lt; k * sigma)</a:t>
+            </a:r>
+          </a:p>
+          <a:p>
+            <a:pPr>
+              <a:defRPr sz="1200" b="0">
+                <a:solidFill>
+                  <a:srgbClr val="F8FAFC"/>
+                </a:solidFill>
+                <a:latin typeface="Courier New"/>
+              </a:defRPr>
+            </a:pPr>
+            <a:r>
+              <a:rPr sz="1200" b="0">
+                <a:solidFill>
+                  <a:srgbClr val="F8FAFC"/>
+                </a:solidFill>
+                <a:latin typeface="Courier New"/>
+              </a:rPr>
+              <a:t>    print(f"  dentro de {k} sigma: {frac:.3f}")</a:t>
+            </a:r>
+          </a:p>
+          <a:p>
+            <a:pPr>
+              <a:defRPr sz="1200" b="0">
+                <a:solidFill>
+                  <a:srgbClr val="F8FAFC"/>
+                </a:solidFill>
+                <a:latin typeface="Courier New"/>
+              </a:defRPr>
+            </a:pPr>
+            <a:r>
+              <a:rPr sz="1200" b="0">
+                <a:solidFill>
+                  <a:srgbClr val="F8FAFC"/>
+                </a:solidFill>
+                <a:latin typeface="Courier New"/>
+              </a:rPr>
+              <a:t>frac1 = np.mean(np.abs(x - mu) &lt; sigma)</a:t>
+            </a:r>
+          </a:p>
+          <a:p>
+            <a:pPr>
+              <a:defRPr sz="1200" b="0">
+                <a:solidFill>
+                  <a:srgbClr val="F8FAFC"/>
+                </a:solidFill>
+                <a:latin typeface="Courier New"/>
+              </a:defRPr>
+            </a:pPr>
+            <a:r>
+              <a:rPr sz="1200" b="0">
+                <a:solidFill>
+                  <a:srgbClr val="F8FAFC"/>
+                </a:solidFill>
+                <a:latin typeface="Courier New"/>
+              </a:rPr>
+              <a:t>assert abs(frac1 - 0.683) &lt; 0.02, "la regla 68-95-99.7 debe cumplirse"</a:t>
+            </a:r>
+          </a:p>
+          <a:p>
+            <a:pPr>
+              <a:defRPr sz="1200" b="0">
+                <a:solidFill>
+                  <a:srgbClr val="F8FAFC"/>
+                </a:solidFill>
+                <a:latin typeface="Courier New"/>
+              </a:defRPr>
+            </a:pPr>
+            <a:r>
+              <a:rPr sz="1200" b="0">
+                <a:solidFill>
+                  <a:srgbClr val="F8FAFC"/>
+                </a:solidFill>
+                <a:latin typeface="Courier New"/>
+              </a:rPr>
+              <a:t> </a:t>
+            </a:r>
+          </a:p>
+          <a:p>
+            <a:pPr>
+              <a:defRPr sz="1200" b="0">
+                <a:solidFill>
+                  <a:srgbClr val="F8FAFC"/>
+                </a:solidFill>
+                <a:latin typeface="Courier New"/>
+              </a:defRPr>
+            </a:pPr>
+            <a:r>
+              <a:rPr sz="1200" b="0">
+                <a:solidFill>
+                  <a:srgbClr val="F8FAFC"/>
+                </a:solidFill>
+                <a:latin typeface="Courier New"/>
+              </a:rPr>
+              <a:t>grid = np.linspace(mu - 4*sigma, mu + 4*sigma, 200)</a:t>
+            </a:r>
+          </a:p>
+          <a:p>
+            <a:pPr>
+              <a:defRPr sz="1200" b="0">
+                <a:solidFill>
+                  <a:srgbClr val="F8FAFC"/>
+                </a:solidFill>
+                <a:latin typeface="Courier New"/>
+              </a:defRPr>
+            </a:pPr>
+            <a:r>
+              <a:rPr sz="1200" b="0">
+                <a:solidFill>
+                  <a:srgbClr val="F8FAFC"/>
+                </a:solidFill>
+                <a:latin typeface="Courier New"/>
+              </a:rPr>
+              <a:t>plt.figure(figsize=(7, 4))</a:t>
+            </a:r>
+          </a:p>
+          <a:p>
+            <a:pPr>
+              <a:defRPr sz="1200" b="0">
+                <a:solidFill>
+                  <a:srgbClr val="F8FAFC"/>
+                </a:solidFill>
+                <a:latin typeface="Courier New"/>
+              </a:defRPr>
+            </a:pPr>
+            <a:r>
+              <a:rPr sz="1200" b="0">
+                <a:solidFill>
+                  <a:srgbClr val="F8FAFC"/>
+                </a:solidFill>
+                <a:latin typeface="Courier New"/>
+              </a:rPr>
+              <a:t>plt.hist(x, bins=50, density=True, alpha=0.5, label="muestra")</a:t>
+            </a:r>
+          </a:p>
+          <a:p>
+            <a:pPr>
+              <a:defRPr sz="1200" b="0">
+                <a:solidFill>
+                  <a:srgbClr val="F8FAFC"/>
+                </a:solidFill>
+                <a:latin typeface="Courier New"/>
+              </a:defRPr>
+            </a:pPr>
+            <a:r>
+              <a:rPr sz="1200" b="0">
+                <a:solidFill>
+                  <a:srgbClr val="F8FAFC"/>
+                </a:solidFill>
+                <a:latin typeface="Courier New"/>
+              </a:rPr>
+              <a:t># ... (truncado)</a:t>
             </a:r>
           </a:p>
         </p:txBody>
@@ -31832,7 +34910,7 @@
                 </a:solidFill>
                 <a:latin typeface="Segoe UI"/>
               </a:rPr>
-              <a:t>Primer bloque ejecutable del notebook.</a:t>
+              <a:t>T ← Z → Y. Z causa tanto T como Y. El OLS ingenuo Y~T está sesgado; ajustar por Z recupera el efecto causal (backdoor criterion).</a:t>
             </a:r>
           </a:p>
         </p:txBody>
@@ -31919,7 +34997,368 @@
                 </a:solidFill>
                 <a:latin typeface="Courier New"/>
               </a:rPr>
-              <a:t># Imports y configuración inicial</a:t>
+              <a:t>import numpy as np</a:t>
+            </a:r>
+          </a:p>
+          <a:p>
+            <a:pPr>
+              <a:defRPr sz="1200" b="0">
+                <a:solidFill>
+                  <a:srgbClr val="F8FAFC"/>
+                </a:solidFill>
+                <a:latin typeface="Courier New"/>
+              </a:defRPr>
+            </a:pPr>
+            <a:r>
+              <a:rPr sz="1200" b="0">
+                <a:solidFill>
+                  <a:srgbClr val="F8FAFC"/>
+                </a:solidFill>
+                <a:latin typeface="Courier New"/>
+              </a:rPr>
+              <a:t>import pandas as pd</a:t>
+            </a:r>
+          </a:p>
+          <a:p>
+            <a:pPr>
+              <a:defRPr sz="1200" b="0">
+                <a:solidFill>
+                  <a:srgbClr val="F8FAFC"/>
+                </a:solidFill>
+                <a:latin typeface="Courier New"/>
+              </a:defRPr>
+            </a:pPr>
+            <a:r>
+              <a:rPr sz="1200" b="0">
+                <a:solidFill>
+                  <a:srgbClr val="F8FAFC"/>
+                </a:solidFill>
+                <a:latin typeface="Courier New"/>
+              </a:rPr>
+              <a:t>import statsmodels.api as sm</a:t>
+            </a:r>
+          </a:p>
+          <a:p>
+            <a:pPr>
+              <a:defRPr sz="1200" b="0">
+                <a:solidFill>
+                  <a:srgbClr val="F8FAFC"/>
+                </a:solidFill>
+                <a:latin typeface="Courier New"/>
+              </a:defRPr>
+            </a:pPr>
+            <a:r>
+              <a:rPr sz="1200" b="0">
+                <a:solidFill>
+                  <a:srgbClr val="F8FAFC"/>
+                </a:solidFill>
+                <a:latin typeface="Courier New"/>
+              </a:rPr>
+              <a:t>import statsmodels.formula.api as smf</a:t>
+            </a:r>
+          </a:p>
+          <a:p>
+            <a:pPr>
+              <a:defRPr sz="1200" b="0">
+                <a:solidFill>
+                  <a:srgbClr val="F8FAFC"/>
+                </a:solidFill>
+                <a:latin typeface="Courier New"/>
+              </a:defRPr>
+            </a:pPr>
+            <a:r>
+              <a:rPr sz="1200" b="0">
+                <a:solidFill>
+                  <a:srgbClr val="F8FAFC"/>
+                </a:solidFill>
+                <a:latin typeface="Courier New"/>
+              </a:rPr>
+              <a:t>from statsmodels.sandbox.regression.gmm import IV2SLS</a:t>
+            </a:r>
+          </a:p>
+          <a:p>
+            <a:pPr>
+              <a:defRPr sz="1200" b="0">
+                <a:solidFill>
+                  <a:srgbClr val="F8FAFC"/>
+                </a:solidFill>
+                <a:latin typeface="Courier New"/>
+              </a:defRPr>
+            </a:pPr>
+            <a:r>
+              <a:rPr sz="1200" b="0">
+                <a:solidFill>
+                  <a:srgbClr val="F8FAFC"/>
+                </a:solidFill>
+                <a:latin typeface="Courier New"/>
+              </a:rPr>
+              <a:t>import matplotlib.pyplot as plt</a:t>
+            </a:r>
+          </a:p>
+          <a:p>
+            <a:pPr>
+              <a:defRPr sz="1200" b="0">
+                <a:solidFill>
+                  <a:srgbClr val="F8FAFC"/>
+                </a:solidFill>
+                <a:latin typeface="Courier New"/>
+              </a:defRPr>
+            </a:pPr>
+            <a:r>
+              <a:rPr sz="1200" b="0">
+                <a:solidFill>
+                  <a:srgbClr val="F8FAFC"/>
+                </a:solidFill>
+                <a:latin typeface="Courier New"/>
+              </a:rPr>
+              <a:t> </a:t>
+            </a:r>
+          </a:p>
+          <a:p>
+            <a:pPr>
+              <a:defRPr sz="1200" b="0">
+                <a:solidFill>
+                  <a:srgbClr val="F8FAFC"/>
+                </a:solidFill>
+                <a:latin typeface="Courier New"/>
+              </a:defRPr>
+            </a:pPr>
+            <a:r>
+              <a:rPr sz="1200" b="0">
+                <a:solidFill>
+                  <a:srgbClr val="F8FAFC"/>
+                </a:solidFill>
+                <a:latin typeface="Courier New"/>
+              </a:rPr>
+              <a:t>rng = np.random.default_rng(42)</a:t>
+            </a:r>
+          </a:p>
+          <a:p>
+            <a:pPr>
+              <a:defRPr sz="1200" b="0">
+                <a:solidFill>
+                  <a:srgbClr val="F8FAFC"/>
+                </a:solidFill>
+                <a:latin typeface="Courier New"/>
+              </a:defRPr>
+            </a:pPr>
+            <a:r>
+              <a:rPr sz="1200" b="0">
+                <a:solidFill>
+                  <a:srgbClr val="F8FAFC"/>
+                </a:solidFill>
+                <a:latin typeface="Courier New"/>
+              </a:rPr>
+              <a:t> </a:t>
+            </a:r>
+          </a:p>
+          <a:p>
+            <a:pPr>
+              <a:defRPr sz="1200" b="0">
+                <a:solidFill>
+                  <a:srgbClr val="F8FAFC"/>
+                </a:solidFill>
+                <a:latin typeface="Courier New"/>
+              </a:defRPr>
+            </a:pPr>
+            <a:r>
+              <a:rPr sz="1200" b="0">
+                <a:solidFill>
+                  <a:srgbClr val="F8FAFC"/>
+                </a:solidFill>
+                <a:latin typeface="Courier New"/>
+              </a:rPr>
+              <a:t>n = 5000</a:t>
+            </a:r>
+          </a:p>
+          <a:p>
+            <a:pPr>
+              <a:defRPr sz="1200" b="0">
+                <a:solidFill>
+                  <a:srgbClr val="F8FAFC"/>
+                </a:solidFill>
+                <a:latin typeface="Courier New"/>
+              </a:defRPr>
+            </a:pPr>
+            <a:r>
+              <a:rPr sz="1200" b="0">
+                <a:solidFill>
+                  <a:srgbClr val="F8FAFC"/>
+                </a:solidFill>
+                <a:latin typeface="Courier New"/>
+              </a:rPr>
+              <a:t>Z = rng.normal(0, 1, n)                     # confounder</a:t>
+            </a:r>
+          </a:p>
+          <a:p>
+            <a:pPr>
+              <a:defRPr sz="1200" b="0">
+                <a:solidFill>
+                  <a:srgbClr val="F8FAFC"/>
+                </a:solidFill>
+                <a:latin typeface="Courier New"/>
+              </a:defRPr>
+            </a:pPr>
+            <a:r>
+              <a:rPr sz="1200" b="0">
+                <a:solidFill>
+                  <a:srgbClr val="F8FAFC"/>
+                </a:solidFill>
+                <a:latin typeface="Courier New"/>
+              </a:rPr>
+              <a:t>T = 0.8 * Z + rng.normal(0, 1, n)           # tratamiento depende de Z</a:t>
+            </a:r>
+          </a:p>
+          <a:p>
+            <a:pPr>
+              <a:defRPr sz="1200" b="0">
+                <a:solidFill>
+                  <a:srgbClr val="F8FAFC"/>
+                </a:solidFill>
+                <a:latin typeface="Courier New"/>
+              </a:defRPr>
+            </a:pPr>
+            <a:r>
+              <a:rPr sz="1200" b="0">
+                <a:solidFill>
+                  <a:srgbClr val="F8FAFC"/>
+                </a:solidFill>
+                <a:latin typeface="Courier New"/>
+              </a:rPr>
+              <a:t>Y = 2.0 * T + 3.0 * Z + rng.normal(0, 1, n) # efecto causal verdadero de T = 2.0</a:t>
+            </a:r>
+          </a:p>
+          <a:p>
+            <a:pPr>
+              <a:defRPr sz="1200" b="0">
+                <a:solidFill>
+                  <a:srgbClr val="F8FAFC"/>
+                </a:solidFill>
+                <a:latin typeface="Courier New"/>
+              </a:defRPr>
+            </a:pPr>
+            <a:r>
+              <a:rPr sz="1200" b="0">
+                <a:solidFill>
+                  <a:srgbClr val="F8FAFC"/>
+                </a:solidFill>
+                <a:latin typeface="Courier New"/>
+              </a:rPr>
+              <a:t>df = pd.DataFrame({"Y": Y, "T": T, "Z": Z})</a:t>
+            </a:r>
+          </a:p>
+          <a:p>
+            <a:pPr>
+              <a:defRPr sz="1200" b="0">
+                <a:solidFill>
+                  <a:srgbClr val="F8FAFC"/>
+                </a:solidFill>
+                <a:latin typeface="Courier New"/>
+              </a:defRPr>
+            </a:pPr>
+            <a:r>
+              <a:rPr sz="1200" b="0">
+                <a:solidFill>
+                  <a:srgbClr val="F8FAFC"/>
+                </a:solidFill>
+                <a:latin typeface="Courier New"/>
+              </a:rPr>
+              <a:t>naive = smf.ols("Y ~ T", data=df).fit().params["T"]</a:t>
+            </a:r>
+          </a:p>
+          <a:p>
+            <a:pPr>
+              <a:defRPr sz="1200" b="0">
+                <a:solidFill>
+                  <a:srgbClr val="F8FAFC"/>
+                </a:solidFill>
+                <a:latin typeface="Courier New"/>
+              </a:defRPr>
+            </a:pPr>
+            <a:r>
+              <a:rPr sz="1200" b="0">
+                <a:solidFill>
+                  <a:srgbClr val="F8FAFC"/>
+                </a:solidFill>
+                <a:latin typeface="Courier New"/>
+              </a:rPr>
+              <a:t>adj   = smf.ols("Y ~ T + Z", data=df).fit().params["T"]</a:t>
+            </a:r>
+          </a:p>
+          <a:p>
+            <a:pPr>
+              <a:defRPr sz="1200" b="0">
+                <a:solidFill>
+                  <a:srgbClr val="F8FAFC"/>
+                </a:solidFill>
+                <a:latin typeface="Courier New"/>
+              </a:defRPr>
+            </a:pPr>
+            <a:r>
+              <a:rPr sz="1200" b="0">
+                <a:solidFill>
+                  <a:srgbClr val="F8FAFC"/>
+                </a:solidFill>
+                <a:latin typeface="Courier New"/>
+              </a:rPr>
+              <a:t>print("efecto verdadero = 2.00")</a:t>
+            </a:r>
+          </a:p>
+          <a:p>
+            <a:pPr>
+              <a:defRPr sz="1200" b="0">
+                <a:solidFill>
+                  <a:srgbClr val="F8FAFC"/>
+                </a:solidFill>
+                <a:latin typeface="Courier New"/>
+              </a:defRPr>
+            </a:pPr>
+            <a:r>
+              <a:rPr sz="1200" b="0">
+                <a:solidFill>
+                  <a:srgbClr val="F8FAFC"/>
+                </a:solidFill>
+                <a:latin typeface="Courier New"/>
+              </a:rPr>
+              <a:t>print(f"OLS ingenuo   Y~T   = {naive:.3f}  (sesgado por Z)")</a:t>
+            </a:r>
+          </a:p>
+          <a:p>
+            <a:pPr>
+              <a:defRPr sz="1200" b="0">
+                <a:solidFill>
+                  <a:srgbClr val="F8FAFC"/>
+                </a:solidFill>
+                <a:latin typeface="Courier New"/>
+              </a:defRPr>
+            </a:pPr>
+            <a:r>
+              <a:rPr sz="1200" b="0">
+                <a:solidFill>
+                  <a:srgbClr val="F8FAFC"/>
+                </a:solidFill>
+                <a:latin typeface="Courier New"/>
+              </a:rPr>
+              <a:t>print(f"OLS ajustado  Y~T+Z = {adj:.3f}  (recupera el efecto)")</a:t>
+            </a:r>
+          </a:p>
+          <a:p>
+            <a:pPr>
+              <a:defRPr sz="1200" b="0">
+                <a:solidFill>
+                  <a:srgbClr val="F8FAFC"/>
+                </a:solidFill>
+                <a:latin typeface="Courier New"/>
+              </a:defRPr>
+            </a:pPr>
+            <a:r>
+              <a:rPr sz="1200" b="0">
+                <a:solidFill>
+                  <a:srgbClr val="F8FAFC"/>
+                </a:solidFill>
+                <a:latin typeface="Courier New"/>
+              </a:rPr>
+              <a:t>assert abs(adj - 2.0) &lt; 0.15 and abs(naive - 2.0) &gt; 0.3</a:t>
             </a:r>
           </a:p>
         </p:txBody>
@@ -36784,7 +40223,7 @@
                 </a:solidFill>
                 <a:latin typeface="Segoe UI"/>
               </a:rPr>
-              <a:t>Primer bloque ejecutable del notebook.</a:t>
+              <a:t>Y = β₀ + β₁·tratado + β₂·post + β₃·(tratado×post) + ε. El coeficiente β₃ es el efecto causal bajo parallel trends.</a:t>
             </a:r>
           </a:p>
         </p:txBody>
@@ -36871,7 +40310,349 @@
                 </a:solidFill>
                 <a:latin typeface="Courier New"/>
               </a:rPr>
-              <a:t># Imports y configuración inicial</a:t>
+              <a:t>import numpy as np</a:t>
+            </a:r>
+          </a:p>
+          <a:p>
+            <a:pPr>
+              <a:defRPr sz="1200" b="0">
+                <a:solidFill>
+                  <a:srgbClr val="F8FAFC"/>
+                </a:solidFill>
+                <a:latin typeface="Courier New"/>
+              </a:defRPr>
+            </a:pPr>
+            <a:r>
+              <a:rPr sz="1200" b="0">
+                <a:solidFill>
+                  <a:srgbClr val="F8FAFC"/>
+                </a:solidFill>
+                <a:latin typeface="Courier New"/>
+              </a:rPr>
+              <a:t>import pandas as pd</a:t>
+            </a:r>
+          </a:p>
+          <a:p>
+            <a:pPr>
+              <a:defRPr sz="1200" b="0">
+                <a:solidFill>
+                  <a:srgbClr val="F8FAFC"/>
+                </a:solidFill>
+                <a:latin typeface="Courier New"/>
+              </a:defRPr>
+            </a:pPr>
+            <a:r>
+              <a:rPr sz="1200" b="0">
+                <a:solidFill>
+                  <a:srgbClr val="F8FAFC"/>
+                </a:solidFill>
+                <a:latin typeface="Courier New"/>
+              </a:rPr>
+              <a:t>import statsmodels.formula.api as smf</a:t>
+            </a:r>
+          </a:p>
+          <a:p>
+            <a:pPr>
+              <a:defRPr sz="1200" b="0">
+                <a:solidFill>
+                  <a:srgbClr val="F8FAFC"/>
+                </a:solidFill>
+                <a:latin typeface="Courier New"/>
+              </a:defRPr>
+            </a:pPr>
+            <a:r>
+              <a:rPr sz="1200" b="0">
+                <a:solidFill>
+                  <a:srgbClr val="F8FAFC"/>
+                </a:solidFill>
+                <a:latin typeface="Courier New"/>
+              </a:rPr>
+              <a:t>from sklearn.ensemble import RandomForestClassifier</a:t>
+            </a:r>
+          </a:p>
+          <a:p>
+            <a:pPr>
+              <a:defRPr sz="1200" b="0">
+                <a:solidFill>
+                  <a:srgbClr val="F8FAFC"/>
+                </a:solidFill>
+                <a:latin typeface="Courier New"/>
+              </a:defRPr>
+            </a:pPr>
+            <a:r>
+              <a:rPr sz="1200" b="0">
+                <a:solidFill>
+                  <a:srgbClr val="F8FAFC"/>
+                </a:solidFill>
+                <a:latin typeface="Courier New"/>
+              </a:rPr>
+              <a:t>import matplotlib.pyplot as plt</a:t>
+            </a:r>
+          </a:p>
+          <a:p>
+            <a:pPr>
+              <a:defRPr sz="1200" b="0">
+                <a:solidFill>
+                  <a:srgbClr val="F8FAFC"/>
+                </a:solidFill>
+                <a:latin typeface="Courier New"/>
+              </a:defRPr>
+            </a:pPr>
+            <a:r>
+              <a:rPr sz="1200" b="0">
+                <a:solidFill>
+                  <a:srgbClr val="F8FAFC"/>
+                </a:solidFill>
+                <a:latin typeface="Courier New"/>
+              </a:rPr>
+              <a:t> </a:t>
+            </a:r>
+          </a:p>
+          <a:p>
+            <a:pPr>
+              <a:defRPr sz="1200" b="0">
+                <a:solidFill>
+                  <a:srgbClr val="F8FAFC"/>
+                </a:solidFill>
+                <a:latin typeface="Courier New"/>
+              </a:defRPr>
+            </a:pPr>
+            <a:r>
+              <a:rPr sz="1200" b="0">
+                <a:solidFill>
+                  <a:srgbClr val="F8FAFC"/>
+                </a:solidFill>
+                <a:latin typeface="Courier New"/>
+              </a:rPr>
+              <a:t>rng = np.random.default_rng(42)</a:t>
+            </a:r>
+          </a:p>
+          <a:p>
+            <a:pPr>
+              <a:defRPr sz="1200" b="0">
+                <a:solidFill>
+                  <a:srgbClr val="F8FAFC"/>
+                </a:solidFill>
+                <a:latin typeface="Courier New"/>
+              </a:defRPr>
+            </a:pPr>
+            <a:r>
+              <a:rPr sz="1200" b="0">
+                <a:solidFill>
+                  <a:srgbClr val="F8FAFC"/>
+                </a:solidFill>
+                <a:latin typeface="Courier New"/>
+              </a:rPr>
+              <a:t> </a:t>
+            </a:r>
+          </a:p>
+          <a:p>
+            <a:pPr>
+              <a:defRPr sz="1200" b="0">
+                <a:solidFill>
+                  <a:srgbClr val="F8FAFC"/>
+                </a:solidFill>
+                <a:latin typeface="Courier New"/>
+              </a:defRPr>
+            </a:pPr>
+            <a:r>
+              <a:rPr sz="1200" b="0">
+                <a:solidFill>
+                  <a:srgbClr val="F8FAFC"/>
+                </a:solidFill>
+                <a:latin typeface="Courier New"/>
+              </a:rPr>
+              <a:t>n = 2000</a:t>
+            </a:r>
+          </a:p>
+          <a:p>
+            <a:pPr>
+              <a:defRPr sz="1200" b="0">
+                <a:solidFill>
+                  <a:srgbClr val="F8FAFC"/>
+                </a:solidFill>
+                <a:latin typeface="Courier New"/>
+              </a:defRPr>
+            </a:pPr>
+            <a:r>
+              <a:rPr sz="1200" b="0">
+                <a:solidFill>
+                  <a:srgbClr val="F8FAFC"/>
+                </a:solidFill>
+                <a:latin typeface="Courier New"/>
+              </a:rPr>
+              <a:t>treated = rng.integers(0, 2, n)</a:t>
+            </a:r>
+          </a:p>
+          <a:p>
+            <a:pPr>
+              <a:defRPr sz="1200" b="0">
+                <a:solidFill>
+                  <a:srgbClr val="F8FAFC"/>
+                </a:solidFill>
+                <a:latin typeface="Courier New"/>
+              </a:defRPr>
+            </a:pPr>
+            <a:r>
+              <a:rPr sz="1200" b="0">
+                <a:solidFill>
+                  <a:srgbClr val="F8FAFC"/>
+                </a:solidFill>
+                <a:latin typeface="Courier New"/>
+              </a:rPr>
+              <a:t>post = rng.integers(0, 2, n)</a:t>
+            </a:r>
+          </a:p>
+          <a:p>
+            <a:pPr>
+              <a:defRPr sz="1200" b="0">
+                <a:solidFill>
+                  <a:srgbClr val="F8FAFC"/>
+                </a:solidFill>
+                <a:latin typeface="Courier New"/>
+              </a:defRPr>
+            </a:pPr>
+            <a:r>
+              <a:rPr sz="1200" b="0">
+                <a:solidFill>
+                  <a:srgbClr val="F8FAFC"/>
+                </a:solidFill>
+                <a:latin typeface="Courier New"/>
+              </a:rPr>
+              <a:t>true_effect = 2.5</a:t>
+            </a:r>
+          </a:p>
+          <a:p>
+            <a:pPr>
+              <a:defRPr sz="1200" b="0">
+                <a:solidFill>
+                  <a:srgbClr val="F8FAFC"/>
+                </a:solidFill>
+                <a:latin typeface="Courier New"/>
+              </a:defRPr>
+            </a:pPr>
+            <a:r>
+              <a:rPr sz="1200" b="0">
+                <a:solidFill>
+                  <a:srgbClr val="F8FAFC"/>
+                </a:solidFill>
+                <a:latin typeface="Courier New"/>
+              </a:rPr>
+              <a:t>Y = 10 + 1.5*treated + 3.0*post + true_effect*(treated*post) + rng.normal(0, 2, n)</a:t>
+            </a:r>
+          </a:p>
+          <a:p>
+            <a:pPr>
+              <a:defRPr sz="1200" b="0">
+                <a:solidFill>
+                  <a:srgbClr val="F8FAFC"/>
+                </a:solidFill>
+                <a:latin typeface="Courier New"/>
+              </a:defRPr>
+            </a:pPr>
+            <a:r>
+              <a:rPr sz="1200" b="0">
+                <a:solidFill>
+                  <a:srgbClr val="F8FAFC"/>
+                </a:solidFill>
+                <a:latin typeface="Courier New"/>
+              </a:rPr>
+              <a:t>df = pd.DataFrame({"Y": Y, "treated": treated, "post": post})</a:t>
+            </a:r>
+          </a:p>
+          <a:p>
+            <a:pPr>
+              <a:defRPr sz="1200" b="0">
+                <a:solidFill>
+                  <a:srgbClr val="F8FAFC"/>
+                </a:solidFill>
+                <a:latin typeface="Courier New"/>
+              </a:defRPr>
+            </a:pPr>
+            <a:r>
+              <a:rPr sz="1200" b="0">
+                <a:solidFill>
+                  <a:srgbClr val="F8FAFC"/>
+                </a:solidFill>
+                <a:latin typeface="Courier New"/>
+              </a:rPr>
+              <a:t>m = smf.ols("Y ~ treated * post", data=df).fit()</a:t>
+            </a:r>
+          </a:p>
+          <a:p>
+            <a:pPr>
+              <a:defRPr sz="1200" b="0">
+                <a:solidFill>
+                  <a:srgbClr val="F8FAFC"/>
+                </a:solidFill>
+                <a:latin typeface="Courier New"/>
+              </a:defRPr>
+            </a:pPr>
+            <a:r>
+              <a:rPr sz="1200" b="0">
+                <a:solidFill>
+                  <a:srgbClr val="F8FAFC"/>
+                </a:solidFill>
+                <a:latin typeface="Courier New"/>
+              </a:rPr>
+              <a:t>beta3 = m.params["treated:post"]</a:t>
+            </a:r>
+          </a:p>
+          <a:p>
+            <a:pPr>
+              <a:defRPr sz="1200" b="0">
+                <a:solidFill>
+                  <a:srgbClr val="F8FAFC"/>
+                </a:solidFill>
+                <a:latin typeface="Courier New"/>
+              </a:defRPr>
+            </a:pPr>
+            <a:r>
+              <a:rPr sz="1200" b="0">
+                <a:solidFill>
+                  <a:srgbClr val="F8FAFC"/>
+                </a:solidFill>
+                <a:latin typeface="Courier New"/>
+              </a:rPr>
+              <a:t>ci = m.conf_int().loc["treated:post"]</a:t>
+            </a:r>
+          </a:p>
+          <a:p>
+            <a:pPr>
+              <a:defRPr sz="1200" b="0">
+                <a:solidFill>
+                  <a:srgbClr val="F8FAFC"/>
+                </a:solidFill>
+                <a:latin typeface="Courier New"/>
+              </a:defRPr>
+            </a:pPr>
+            <a:r>
+              <a:rPr sz="1200" b="0">
+                <a:solidFill>
+                  <a:srgbClr val="F8FAFC"/>
+                </a:solidFill>
+                <a:latin typeface="Courier New"/>
+              </a:rPr>
+              <a:t>print(f"DiD β3 = {beta3:.3f}  IC95%=({ci[0]:.3f}, {ci[1]:.3f})  verdadero={true_effect}")</a:t>
+            </a:r>
+          </a:p>
+          <a:p>
+            <a:pPr>
+              <a:defRPr sz="1200" b="0">
+                <a:solidFill>
+                  <a:srgbClr val="F8FAFC"/>
+                </a:solidFill>
+                <a:latin typeface="Courier New"/>
+              </a:defRPr>
+            </a:pPr>
+            <a:r>
+              <a:rPr sz="1200" b="0">
+                <a:solidFill>
+                  <a:srgbClr val="F8FAFC"/>
+                </a:solidFill>
+                <a:latin typeface="Courier New"/>
+              </a:rPr>
+              <a:t>assert abs(beta3 - true_effect) &lt; 0.5</a:t>
             </a:r>
           </a:p>
         </p:txBody>
@@ -41387,7 +45168,7 @@
                 </a:solidFill>
                 <a:latin typeface="Segoe UI"/>
               </a:rPr>
-              <a:t>Primer bloque ejecutable del notebook.</a:t>
+              <a:t>Con prior Beta(1,1) (uniforme) y datos binomiales, el posterior es Beta(a+éxitos, b+fracasos) — sin necesidad de MCMC. Calculamos el intervalo del 94 % con scipy.</a:t>
             </a:r>
           </a:p>
         </p:txBody>
@@ -41474,7 +45255,368 @@
                 </a:solidFill>
                 <a:latin typeface="Courier New"/>
               </a:rPr>
-              <a:t># Imports y configuración inicial</a:t>
+              <a:t>import numpy as np</a:t>
+            </a:r>
+          </a:p>
+          <a:p>
+            <a:pPr>
+              <a:defRPr sz="1200" b="0">
+                <a:solidFill>
+                  <a:srgbClr val="F8FAFC"/>
+                </a:solidFill>
+                <a:latin typeface="Courier New"/>
+              </a:defRPr>
+            </a:pPr>
+            <a:r>
+              <a:rPr sz="1200" b="0">
+                <a:solidFill>
+                  <a:srgbClr val="F8FAFC"/>
+                </a:solidFill>
+                <a:latin typeface="Courier New"/>
+              </a:rPr>
+              <a:t>from scipy import stats</a:t>
+            </a:r>
+          </a:p>
+          <a:p>
+            <a:pPr>
+              <a:defRPr sz="1200" b="0">
+                <a:solidFill>
+                  <a:srgbClr val="F8FAFC"/>
+                </a:solidFill>
+                <a:latin typeface="Courier New"/>
+              </a:defRPr>
+            </a:pPr>
+            <a:r>
+              <a:rPr sz="1200" b="0">
+                <a:solidFill>
+                  <a:srgbClr val="F8FAFC"/>
+                </a:solidFill>
+                <a:latin typeface="Courier New"/>
+              </a:rPr>
+              <a:t>import matplotlib.pyplot as plt</a:t>
+            </a:r>
+          </a:p>
+          <a:p>
+            <a:pPr>
+              <a:defRPr sz="1200" b="0">
+                <a:solidFill>
+                  <a:srgbClr val="F8FAFC"/>
+                </a:solidFill>
+                <a:latin typeface="Courier New"/>
+              </a:defRPr>
+            </a:pPr>
+            <a:r>
+              <a:rPr sz="1200" b="0">
+                <a:solidFill>
+                  <a:srgbClr val="F8FAFC"/>
+                </a:solidFill>
+                <a:latin typeface="Courier New"/>
+              </a:rPr>
+              <a:t> </a:t>
+            </a:r>
+          </a:p>
+          <a:p>
+            <a:pPr>
+              <a:defRPr sz="1200" b="0">
+                <a:solidFill>
+                  <a:srgbClr val="F8FAFC"/>
+                </a:solidFill>
+                <a:latin typeface="Courier New"/>
+              </a:defRPr>
+            </a:pPr>
+            <a:r>
+              <a:rPr sz="1200" b="0">
+                <a:solidFill>
+                  <a:srgbClr val="F8FAFC"/>
+                </a:solidFill>
+                <a:latin typeface="Courier New"/>
+              </a:rPr>
+              <a:t># 100 visitas, 8 conversiones. Prior Beta(1,1)</a:t>
+            </a:r>
+          </a:p>
+          <a:p>
+            <a:pPr>
+              <a:defRPr sz="1200" b="0">
+                <a:solidFill>
+                  <a:srgbClr val="F8FAFC"/>
+                </a:solidFill>
+                <a:latin typeface="Courier New"/>
+              </a:defRPr>
+            </a:pPr>
+            <a:r>
+              <a:rPr sz="1200" b="0">
+                <a:solidFill>
+                  <a:srgbClr val="F8FAFC"/>
+                </a:solidFill>
+                <a:latin typeface="Courier New"/>
+              </a:rPr>
+              <a:t>visitas, conversiones = 100, 8</a:t>
+            </a:r>
+          </a:p>
+          <a:p>
+            <a:pPr>
+              <a:defRPr sz="1200" b="0">
+                <a:solidFill>
+                  <a:srgbClr val="F8FAFC"/>
+                </a:solidFill>
+                <a:latin typeface="Courier New"/>
+              </a:defRPr>
+            </a:pPr>
+            <a:r>
+              <a:rPr sz="1200" b="0">
+                <a:solidFill>
+                  <a:srgbClr val="F8FAFC"/>
+                </a:solidFill>
+                <a:latin typeface="Courier New"/>
+              </a:rPr>
+              <a:t>a0, b0 = 1, 1</a:t>
+            </a:r>
+          </a:p>
+          <a:p>
+            <a:pPr>
+              <a:defRPr sz="1200" b="0">
+                <a:solidFill>
+                  <a:srgbClr val="F8FAFC"/>
+                </a:solidFill>
+                <a:latin typeface="Courier New"/>
+              </a:defRPr>
+            </a:pPr>
+            <a:r>
+              <a:rPr sz="1200" b="0">
+                <a:solidFill>
+                  <a:srgbClr val="F8FAFC"/>
+                </a:solidFill>
+                <a:latin typeface="Courier New"/>
+              </a:rPr>
+              <a:t>a_post, b_post = a0 + conversiones, b0 + (visitas - conversiones)   # Beta(9, 93)</a:t>
+            </a:r>
+          </a:p>
+          <a:p>
+            <a:pPr>
+              <a:defRPr sz="1200" b="0">
+                <a:solidFill>
+                  <a:srgbClr val="F8FAFC"/>
+                </a:solidFill>
+                <a:latin typeface="Courier New"/>
+              </a:defRPr>
+            </a:pPr>
+            <a:r>
+              <a:rPr sz="1200" b="0">
+                <a:solidFill>
+                  <a:srgbClr val="F8FAFC"/>
+                </a:solidFill>
+                <a:latin typeface="Courier New"/>
+              </a:rPr>
+              <a:t>post = stats.beta(a_post, b_post)</a:t>
+            </a:r>
+          </a:p>
+          <a:p>
+            <a:pPr>
+              <a:defRPr sz="1200" b="0">
+                <a:solidFill>
+                  <a:srgbClr val="F8FAFC"/>
+                </a:solidFill>
+                <a:latin typeface="Courier New"/>
+              </a:defRPr>
+            </a:pPr>
+            <a:r>
+              <a:rPr sz="1200" b="0">
+                <a:solidFill>
+                  <a:srgbClr val="F8FAFC"/>
+                </a:solidFill>
+                <a:latin typeface="Courier New"/>
+              </a:rPr>
+              <a:t>lo, hi = post.ppf(0.03), post.ppf(0.97)    # intervalo central del 94%</a:t>
+            </a:r>
+          </a:p>
+          <a:p>
+            <a:pPr>
+              <a:defRPr sz="1200" b="0">
+                <a:solidFill>
+                  <a:srgbClr val="F8FAFC"/>
+                </a:solidFill>
+                <a:latin typeface="Courier New"/>
+              </a:defRPr>
+            </a:pPr>
+            <a:r>
+              <a:rPr sz="1200" b="0">
+                <a:solidFill>
+                  <a:srgbClr val="F8FAFC"/>
+                </a:solidFill>
+                <a:latin typeface="Courier New"/>
+              </a:rPr>
+              <a:t>print(f"Posterior = Beta({a_post}, {b_post})")</a:t>
+            </a:r>
+          </a:p>
+          <a:p>
+            <a:pPr>
+              <a:defRPr sz="1200" b="0">
+                <a:solidFill>
+                  <a:srgbClr val="F8FAFC"/>
+                </a:solidFill>
+                <a:latin typeface="Courier New"/>
+              </a:defRPr>
+            </a:pPr>
+            <a:r>
+              <a:rPr sz="1200" b="0">
+                <a:solidFill>
+                  <a:srgbClr val="F8FAFC"/>
+                </a:solidFill>
+                <a:latin typeface="Courier New"/>
+              </a:rPr>
+              <a:t>print(f"media posterior = {post.mean():.3f}")</a:t>
+            </a:r>
+          </a:p>
+          <a:p>
+            <a:pPr>
+              <a:defRPr sz="1200" b="0">
+                <a:solidFill>
+                  <a:srgbClr val="F8FAFC"/>
+                </a:solidFill>
+                <a:latin typeface="Courier New"/>
+              </a:defRPr>
+            </a:pPr>
+            <a:r>
+              <a:rPr sz="1200" b="0">
+                <a:solidFill>
+                  <a:srgbClr val="F8FAFC"/>
+                </a:solidFill>
+                <a:latin typeface="Courier New"/>
+              </a:rPr>
+              <a:t>print(f"intervalo 94% = ({lo:.3f}, {hi:.3f})")</a:t>
+            </a:r>
+          </a:p>
+          <a:p>
+            <a:pPr>
+              <a:defRPr sz="1200" b="0">
+                <a:solidFill>
+                  <a:srgbClr val="F8FAFC"/>
+                </a:solidFill>
+                <a:latin typeface="Courier New"/>
+              </a:defRPr>
+            </a:pPr>
+            <a:r>
+              <a:rPr sz="1200" b="0">
+                <a:solidFill>
+                  <a:srgbClr val="F8FAFC"/>
+                </a:solidFill>
+                <a:latin typeface="Courier New"/>
+              </a:rPr>
+              <a:t> </a:t>
+            </a:r>
+          </a:p>
+          <a:p>
+            <a:pPr>
+              <a:defRPr sz="1200" b="0">
+                <a:solidFill>
+                  <a:srgbClr val="F8FAFC"/>
+                </a:solidFill>
+                <a:latin typeface="Courier New"/>
+              </a:defRPr>
+            </a:pPr>
+            <a:r>
+              <a:rPr sz="1200" b="0">
+                <a:solidFill>
+                  <a:srgbClr val="F8FAFC"/>
+                </a:solidFill>
+                <a:latin typeface="Courier New"/>
+              </a:rPr>
+              <a:t>grid = np.linspace(0, 0.25, 300)</a:t>
+            </a:r>
+          </a:p>
+          <a:p>
+            <a:pPr>
+              <a:defRPr sz="1200" b="0">
+                <a:solidFill>
+                  <a:srgbClr val="F8FAFC"/>
+                </a:solidFill>
+                <a:latin typeface="Courier New"/>
+              </a:defRPr>
+            </a:pPr>
+            <a:r>
+              <a:rPr sz="1200" b="0">
+                <a:solidFill>
+                  <a:srgbClr val="F8FAFC"/>
+                </a:solidFill>
+                <a:latin typeface="Courier New"/>
+              </a:rPr>
+              <a:t>plt.figure(figsize=(7, 4))</a:t>
+            </a:r>
+          </a:p>
+          <a:p>
+            <a:pPr>
+              <a:defRPr sz="1200" b="0">
+                <a:solidFill>
+                  <a:srgbClr val="F8FAFC"/>
+                </a:solidFill>
+                <a:latin typeface="Courier New"/>
+              </a:defRPr>
+            </a:pPr>
+            <a:r>
+              <a:rPr sz="1200" b="0">
+                <a:solidFill>
+                  <a:srgbClr val="F8FAFC"/>
+                </a:solidFill>
+                <a:latin typeface="Courier New"/>
+              </a:rPr>
+              <a:t>plt.plot(grid, stats.beta(a0, b0).pdf(grid), label="prior Beta(1,1)")</a:t>
+            </a:r>
+          </a:p>
+          <a:p>
+            <a:pPr>
+              <a:defRPr sz="1200" b="0">
+                <a:solidFill>
+                  <a:srgbClr val="F8FAFC"/>
+                </a:solidFill>
+                <a:latin typeface="Courier New"/>
+              </a:defRPr>
+            </a:pPr>
+            <a:r>
+              <a:rPr sz="1200" b="0">
+                <a:solidFill>
+                  <a:srgbClr val="F8FAFC"/>
+                </a:solidFill>
+                <a:latin typeface="Courier New"/>
+              </a:rPr>
+              <a:t>plt.plot(grid, post.pdf(grid), label=f"posterior Beta({a_post},{b_post})")</a:t>
+            </a:r>
+          </a:p>
+          <a:p>
+            <a:pPr>
+              <a:defRPr sz="1200" b="0">
+                <a:solidFill>
+                  <a:srgbClr val="F8FAFC"/>
+                </a:solidFill>
+                <a:latin typeface="Courier New"/>
+              </a:defRPr>
+            </a:pPr>
+            <a:r>
+              <a:rPr sz="1200" b="0">
+                <a:solidFill>
+                  <a:srgbClr val="F8FAFC"/>
+                </a:solidFill>
+                <a:latin typeface="Courier New"/>
+              </a:rPr>
+              <a:t>plt.title("Actualización bayesiana: prior -&gt; posterior"); plt.legend()</a:t>
+            </a:r>
+          </a:p>
+          <a:p>
+            <a:pPr>
+              <a:defRPr sz="1200" b="0">
+                <a:solidFill>
+                  <a:srgbClr val="F8FAFC"/>
+                </a:solidFill>
+                <a:latin typeface="Courier New"/>
+              </a:defRPr>
+            </a:pPr>
+            <a:r>
+              <a:rPr sz="1200" b="0">
+                <a:solidFill>
+                  <a:srgbClr val="F8FAFC"/>
+                </a:solidFill>
+                <a:latin typeface="Courier New"/>
+              </a:rPr>
+              <a:t>plt.tight_layout(); plt.show()</a:t>
             </a:r>
           </a:p>
         </p:txBody>

</xml_diff>